<commit_message>
Move the deck onto the new UI and palette
Indigo on slate to match the product and lablab, new screenshots, and a slide
for the upload — which is the difference between a dashboard and something a
judge can put their own document into.

Co-Authored-By: Claude Opus 5 <noreply@anthropic.com>
</commit_message>
<xml_diff>
--- a/submission/LastBuy.pptx
+++ b/submission/LastBuy.pptx
@@ -14,9 +14,10 @@
     <p:sldId id="262" r:id="rId8"/>
     <p:sldId id="263" r:id="rId9"/>
     <p:sldId id="264" r:id="rId10"/>
+    <p:sldId id="265" r:id="rId11"/>
   </p:sldIdLst>
   <p:notesMasterIdLst>
-    <p:notesMasterId r:id="rId11"/>
+    <p:notesMasterId r:id="rId12"/>
   </p:notesMasterIdLst>
   <p:sldSz cx="12192000" cy="6858000"/>
   <p:notesSz cx="6858000" cy="12192000"/>
@@ -115,41 +116,42 @@
   <p:extLst>
     <p:ext uri="{521415D9-36F7-43E2-AB2F-B90AF26B5E84}">
       <p14:sectionLst xmlns:p14="http://schemas.microsoft.com/office/powerpoint/2010/main">
-        <p14:section name="Opening" id="{087514cb-66d1-26aa-5cd1-fad58335c5c8}">
+        <p14:section name="Opening" id="{8e27f860-893d-7cb1-8acb-8274060850b0}">
           <p14:sldIdLst>
             <p14:sldId id="256"/>
           </p14:sldIdLst>
         </p14:section>
-        <p14:section name="Problem" id="{a2e26095-5f4d-e8fc-92f3-4168c7699333}">
+        <p14:section name="Problem" id="{5c11416c-498a-74fc-eb36-bc634f3f07b7}">
           <p14:sldIdLst>
             <p14:sldId id="257"/>
           </p14:sldIdLst>
         </p14:section>
-        <p14:section name="Finding" id="{4ee6c322-f03e-b3c6-b013-eb67ccdd444e}">
+        <p14:section name="Finding" id="{584f48f9-f878-7194-91f4-872104e5dc80}">
           <p14:sldIdLst>
             <p14:sldId id="258"/>
           </p14:sldIdLst>
         </p14:section>
-        <p14:section name="How" id="{7114e49d-13ea-9cf2-bd24-10a33fd217e2}">
+        <p14:section name="How" id="{efe63d32-6818-975a-aa75-cde603a7a5a5}">
           <p14:sldIdLst>
             <p14:sldId id="259"/>
             <p14:sldId id="260"/>
           </p14:sldIdLst>
         </p14:section>
-        <p14:section name="Agent" id="{7593d006-b84b-9450-789a-e56b8386f6d9}">
+        <p14:section name="Agent" id="{6071a016-abfb-28f9-9f02-61e97dfeef0c}">
           <p14:sldIdLst>
             <p14:sldId id="261"/>
           </p14:sldIdLst>
         </p14:section>
-        <p14:section name="Product" id="{bd1f8267-38d2-2119-612e-4e1977f0dd5f}">
+        <p14:section name="Product" id="{36306b4a-448f-f6d8-d847-be1c96ef6b14}">
           <p14:sldIdLst>
             <p14:sldId id="262"/>
             <p14:sldId id="263"/>
+            <p14:sldId id="264"/>
           </p14:sldIdLst>
         </p14:section>
-        <p14:section name="Case" id="{456f9c12-7418-914b-ad88-e7f0368b47e1}">
+        <p14:section name="Case" id="{bad029f7-ed07-d60e-81a4-3ada961b5f98}">
           <p14:sldIdLst>
-            <p14:sldId id="264"/>
+            <p14:sldId id="265"/>
           </p14:sldIdLst>
         </p14:section>
       </p14:sectionLst>
@@ -598,6 +600,94 @@
 </p:notes>
 </file>
 
+<file path=ppt/notesSlides/notesSlide10.xml><?xml version="1.0" encoding="utf-8"?>
+<p:notes xmlns:a="http://schemas.openxmlformats.org/drawingml/2006/main" xmlns:r="http://schemas.openxmlformats.org/officeDocument/2006/relationships" xmlns:p="http://schemas.openxmlformats.org/presentationml/2006/main">
+  <p:cSld>
+    <p:spTree>
+      <p:nvGrpSpPr>
+        <p:cNvPr id="1" name=""/>
+        <p:cNvGrpSpPr/>
+        <p:nvPr/>
+      </p:nvGrpSpPr>
+      <p:grpSpPr>
+        <a:xfrm>
+          <a:off x="0" y="0"/>
+          <a:ext cx="0" cy="0"/>
+          <a:chOff x="0" y="0"/>
+          <a:chExt cx="0" cy="0"/>
+        </a:xfrm>
+      </p:grpSpPr>
+      <p:sp>
+        <p:nvSpPr>
+          <p:cNvPr id="2" name="Slide Image Placeholder 1"/>
+          <p:cNvSpPr>
+            <a:spLocks noGrp="1" noRot="1" noChangeAspect="1"/>
+          </p:cNvSpPr>
+          <p:nvPr>
+            <p:ph type="sldImg"/>
+          </p:nvPr>
+        </p:nvSpPr>
+        <p:spPr/>
+      </p:sp>
+      <p:sp>
+        <p:nvSpPr>
+          <p:cNvPr id="3" name="Notes Placeholder 2"/>
+          <p:cNvSpPr>
+            <a:spLocks noGrp="1"/>
+          </p:cNvSpPr>
+          <p:nvPr>
+            <p:ph type="body" idx="1"/>
+          </p:nvPr>
+        </p:nvSpPr>
+        <p:spPr/>
+        <p:txBody>
+          <a:bodyPr/>
+          <a:lstStyle/>
+          <a:p>
+            <a:r>
+              <a:rPr lang="en-US" dirty="0"/>
+              <a:t>Close on the number. No thank-you slide.</a:t>
+            </a:r>
+            <a:endParaRPr lang="en-US" dirty="0"/>
+          </a:p>
+        </p:txBody>
+      </p:sp>
+      <p:sp>
+        <p:nvSpPr>
+          <p:cNvPr id="4" name="Slide Number Placeholder 3"/>
+          <p:cNvSpPr>
+            <a:spLocks noGrp="1"/>
+          </p:cNvSpPr>
+          <p:nvPr>
+            <p:ph type="sldNum" sz="quarter" idx="10"/>
+          </p:nvPr>
+        </p:nvSpPr>
+        <p:spPr/>
+        <p:txBody>
+          <a:bodyPr/>
+          <a:lstStyle/>
+          <a:p>
+            <a:fld id="{F7021451-1387-4CA6-816F-3879F97B5CBC}" type="slidenum">
+              <a:rPr lang="en-US"/>
+              <a:t>10</a:t>
+            </a:fld>
+            <a:endParaRPr lang="en-US"/>
+          </a:p>
+        </p:txBody>
+      </p:sp>
+    </p:spTree>
+    <p:extLst>
+      <p:ext uri="{BB962C8B-B14F-4D97-AF65-F5344CB8AC3E}">
+        <p14:creationId xmlns:p14="http://schemas.microsoft.com/office/powerpoint/2010/main" val="1024086991"/>
+      </p:ext>
+    </p:extLst>
+  </p:cSld>
+  <p:clrMapOvr>
+    <a:masterClrMapping/>
+  </p:clrMapOvr>
+</p:notes>
+</file>
+
 <file path=ppt/notesSlides/notesSlide2.xml><?xml version="1.0" encoding="utf-8"?>
 <p:notes xmlns:a="http://schemas.openxmlformats.org/drawingml/2006/main" xmlns:r="http://schemas.openxmlformats.org/officeDocument/2006/relationships" xmlns:p="http://schemas.openxmlformats.org/presentationml/2006/main">
   <p:cSld>
@@ -1260,7 +1350,7 @@
           <a:p>
             <a:r>
               <a:rPr lang="en-US" dirty="0"/>
-              <a:t>Close on the number. No thank-you slide.</a:t>
+              <a:t>This is the difference between a dashboard and a product you can put work into.</a:t>
             </a:r>
             <a:endParaRPr lang="en-US" dirty="0"/>
           </a:p>
@@ -1338,7 +1428,7 @@
     <p:bg>
       <p:bgPr>
         <a:solidFill>
-          <a:srgbClr val="0F1115"/>
+          <a:srgbClr val="0B1120"/>
         </a:solidFill>
       </p:bgPr>
     </p:bg>
@@ -1454,7 +1544,7 @@
     <p:bg>
       <p:bgPr>
         <a:solidFill>
-          <a:srgbClr val="0F1115"/>
+          <a:srgbClr val="0B1120"/>
         </a:solidFill>
       </p:bgPr>
     </p:bg>
@@ -1541,7 +1631,7 @@
             <a:lvl1pPr>
               <a:defRPr sz="1000">
                 <a:solidFill>
-                  <a:srgbClr val="6B7280"/>
+                  <a:srgbClr val="64748B"/>
                 </a:solidFill>
                 <a:latin typeface="Arial"/>
                 <a:ea typeface="Arial"/>
@@ -1573,7 +1663,7 @@
     <p:bg>
       <p:bgPr>
         <a:solidFill>
-          <a:srgbClr val="0F1115"/>
+          <a:srgbClr val="0B1120"/>
         </a:solidFill>
       </p:bgPr>
     </p:bg>
@@ -1660,7 +1750,7 @@
             <a:lvl1pPr>
               <a:defRPr sz="1000">
                 <a:solidFill>
-                  <a:srgbClr val="6B7280"/>
+                  <a:srgbClr val="64748B"/>
                 </a:solidFill>
                 <a:latin typeface="Arial"/>
                 <a:ea typeface="Arial"/>
@@ -1733,7 +1823,7 @@
             <a:lvl1pPr>
               <a:defRPr sz="1000">
                 <a:solidFill>
-                  <a:srgbClr val="6B7280"/>
+                  <a:srgbClr val="64748B"/>
                 </a:solidFill>
                 <a:latin typeface="Arial"/>
                 <a:ea typeface="Arial"/>
@@ -2137,12 +2227,834 @@
             <a:r>
               <a:rPr lang="en-US" sz="1300" dirty="0">
                 <a:solidFill>
-                  <a:srgbClr val="6B7280"/>
+                  <a:srgbClr val="64748B"/>
                 </a:solidFill>
               </a:rPr>
               <a:t>AMD Developer Hackathon: ACT III   ·   Intelligent Industry   ·   Evolus Business Agents</a:t>
             </a:r>
             <a:endParaRPr lang="en-US" sz="1300" dirty="0"/>
+          </a:p>
+        </p:txBody>
+      </p:sp>
+    </p:spTree>
+  </p:cSld>
+  <p:clrMapOvr>
+    <a:masterClrMapping/>
+  </p:clrMapOvr>
+</p:sld>
+</file>
+
+<file path=ppt/slides/slide10.xml><?xml version="1.0" encoding="utf-8"?>
+<p:sld xmlns:a="http://schemas.openxmlformats.org/drawingml/2006/main" xmlns:r="http://schemas.openxmlformats.org/officeDocument/2006/relationships" xmlns:p="http://schemas.openxmlformats.org/presentationml/2006/main">
+  <p:cSld name="Slide 10">
+    <p:spTree>
+      <p:nvGrpSpPr>
+        <p:cNvPr id="1" name=""/>
+        <p:cNvGrpSpPr/>
+        <p:nvPr/>
+      </p:nvGrpSpPr>
+      <p:grpSpPr>
+        <a:xfrm>
+          <a:off x="0" y="0"/>
+          <a:ext cx="0" cy="0"/>
+          <a:chOff x="0" y="0"/>
+          <a:chExt cx="0" cy="0"/>
+        </a:xfrm>
+      </p:grpSpPr>
+      <p:sp>
+        <p:nvSpPr>
+          <p:cNvPr id="2" name="Text 0"/>
+          <p:cNvSpPr/>
+          <p:nvPr>
+            <p:ph idx="100" type="title" hasCustomPrompt="1"/>
+          </p:nvPr>
+        </p:nvSpPr>
+        <p:spPr>
+          <a:xfrm>
+            <a:off x="640080" y="502920"/>
+            <a:ext cx="10881360" cy="777240"/>
+          </a:xfrm>
+          <a:prstGeom prst="rect">
+            <a:avLst/>
+          </a:prstGeom>
+          <a:noFill/>
+          <a:ln/>
+        </p:spPr>
+        <p:txBody>
+          <a:bodyPr wrap="square" rtlCol="0"/>
+          <a:lstStyle/>
+          <a:p>
+            <a:pPr algn="l" indent="0" marL="0">
+              <a:buNone/>
+            </a:pPr>
+            <a:r>
+              <a:rPr lang="en-US" sz="3600" b="1" dirty="0">
+                <a:solidFill>
+                  <a:schemeClr val="tx1"/>
+                </a:solidFill>
+              </a:rPr>
+              <a:t>People already pay for this, badly</a:t>
+            </a:r>
+            <a:endParaRPr lang="en-US" sz="3600" dirty="0"/>
+          </a:p>
+        </p:txBody>
+      </p:sp>
+      <p:sp>
+        <p:nvSpPr>
+          <p:cNvPr id="3" name="stat-Per assessment"/>
+          <p:cNvSpPr/>
+          <p:nvPr/>
+        </p:nvSpPr>
+        <p:spPr>
+          <a:xfrm>
+            <a:off x="640080" y="1554480"/>
+            <a:ext cx="3520440" cy="1600200"/>
+          </a:xfrm>
+          <a:prstGeom prst="roundRect">
+            <a:avLst>
+              <a:gd name="adj" fmla="val 4571"/>
+            </a:avLst>
+          </a:prstGeom>
+          <a:solidFill>
+            <a:srgbClr val="0F172A"/>
+          </a:solidFill>
+          <a:ln w="12700">
+            <a:solidFill>
+              <a:srgbClr val="1E293B"/>
+            </a:solidFill>
+            <a:prstDash val="solid"/>
+          </a:ln>
+        </p:spPr>
+      </p:sp>
+      <p:sp>
+        <p:nvSpPr>
+          <p:cNvPr id="4" name="Text 2"/>
+          <p:cNvSpPr txBox="1"/>
+          <p:nvPr/>
+        </p:nvSpPr>
+        <p:spPr>
+          <a:xfrm>
+            <a:off x="868680" y="1719072"/>
+            <a:ext cx="3063240" cy="274320"/>
+          </a:xfrm>
+          <a:prstGeom prst="rect">
+            <a:avLst/>
+          </a:prstGeom>
+          <a:noFill/>
+          <a:ln/>
+        </p:spPr>
+        <p:txBody>
+          <a:bodyPr wrap="square" lIns="0" tIns="0" rIns="0" bIns="0" rtlCol="0" anchor="ctr"/>
+          <a:lstStyle/>
+          <a:p>
+            <a:pPr indent="0" marL="0">
+              <a:buNone/>
+            </a:pPr>
+            <a:r>
+              <a:rPr lang="en-US" sz="1100" spc="100" kern="0" dirty="0">
+                <a:solidFill>
+                  <a:srgbClr val="64748B"/>
+                </a:solidFill>
+              </a:rPr>
+              <a:t>PER ASSESSMENT</a:t>
+            </a:r>
+            <a:endParaRPr lang="en-US" sz="1100" dirty="0"/>
+          </a:p>
+        </p:txBody>
+      </p:sp>
+      <p:sp>
+        <p:nvSpPr>
+          <p:cNvPr id="5" name="Text 3"/>
+          <p:cNvSpPr txBox="1"/>
+          <p:nvPr/>
+        </p:nvSpPr>
+        <p:spPr>
+          <a:xfrm>
+            <a:off x="868680" y="2029968"/>
+            <a:ext cx="3063240" cy="658368"/>
+          </a:xfrm>
+          <a:prstGeom prst="rect">
+            <a:avLst/>
+          </a:prstGeom>
+          <a:noFill/>
+          <a:ln/>
+        </p:spPr>
+        <p:txBody>
+          <a:bodyPr wrap="square" lIns="0" tIns="0" rIns="0" bIns="0" rtlCol="0" anchor="ctr"/>
+          <a:lstStyle/>
+          <a:p>
+            <a:pPr indent="0" marL="0">
+              <a:buNone/>
+            </a:pPr>
+            <a:r>
+              <a:rPr lang="en-US" sz="3400" b="1" dirty="0">
+                <a:solidFill>
+                  <a:srgbClr val="E2E8F0"/>
+                </a:solidFill>
+              </a:rPr>
+              <a:t>$0.00012</a:t>
+            </a:r>
+            <a:endParaRPr lang="en-US" sz="3400" dirty="0"/>
+          </a:p>
+        </p:txBody>
+      </p:sp>
+      <p:sp>
+        <p:nvSpPr>
+          <p:cNvPr id="6" name="Text 4"/>
+          <p:cNvSpPr txBox="1"/>
+          <p:nvPr/>
+        </p:nvSpPr>
+        <p:spPr>
+          <a:xfrm>
+            <a:off x="868680" y="2706624"/>
+            <a:ext cx="3063240" cy="292608"/>
+          </a:xfrm>
+          <a:prstGeom prst="rect">
+            <a:avLst/>
+          </a:prstGeom>
+          <a:noFill/>
+          <a:ln/>
+        </p:spPr>
+        <p:txBody>
+          <a:bodyPr wrap="square" lIns="0" tIns="0" rIns="0" bIns="0" rtlCol="0" anchor="ctr"/>
+          <a:lstStyle/>
+          <a:p>
+            <a:pPr indent="0" marL="0">
+              <a:buNone/>
+            </a:pPr>
+            <a:r>
+              <a:rPr lang="en-US" sz="1200" dirty="0">
+                <a:solidFill>
+                  <a:srgbClr val="64748B"/>
+                </a:solidFill>
+              </a:rPr>
+              <a:t>AMD inference, plus 9 Evolus credits</a:t>
+            </a:r>
+            <a:endParaRPr lang="en-US" sz="1200" dirty="0"/>
+          </a:p>
+        </p:txBody>
+      </p:sp>
+      <p:sp>
+        <p:nvSpPr>
+          <p:cNvPr id="7" name="stat-Time"/>
+          <p:cNvSpPr/>
+          <p:nvPr/>
+        </p:nvSpPr>
+        <p:spPr>
+          <a:xfrm>
+            <a:off x="4343400" y="1554480"/>
+            <a:ext cx="3520440" cy="1600200"/>
+          </a:xfrm>
+          <a:prstGeom prst="roundRect">
+            <a:avLst>
+              <a:gd name="adj" fmla="val 4571"/>
+            </a:avLst>
+          </a:prstGeom>
+          <a:solidFill>
+            <a:srgbClr val="0F172A"/>
+          </a:solidFill>
+          <a:ln w="12700">
+            <a:solidFill>
+              <a:srgbClr val="1E293B"/>
+            </a:solidFill>
+            <a:prstDash val="solid"/>
+          </a:ln>
+        </p:spPr>
+      </p:sp>
+      <p:sp>
+        <p:nvSpPr>
+          <p:cNvPr id="8" name="Text 6"/>
+          <p:cNvSpPr txBox="1"/>
+          <p:nvPr/>
+        </p:nvSpPr>
+        <p:spPr>
+          <a:xfrm>
+            <a:off x="4572000" y="1719072"/>
+            <a:ext cx="3063240" cy="274320"/>
+          </a:xfrm>
+          <a:prstGeom prst="rect">
+            <a:avLst/>
+          </a:prstGeom>
+          <a:noFill/>
+          <a:ln/>
+        </p:spPr>
+        <p:txBody>
+          <a:bodyPr wrap="square" lIns="0" tIns="0" rIns="0" bIns="0" rtlCol="0" anchor="ctr"/>
+          <a:lstStyle/>
+          <a:p>
+            <a:pPr indent="0" marL="0">
+              <a:buNone/>
+            </a:pPr>
+            <a:r>
+              <a:rPr lang="en-US" sz="1100" spc="100" kern="0" dirty="0">
+                <a:solidFill>
+                  <a:srgbClr val="64748B"/>
+                </a:solidFill>
+              </a:rPr>
+              <a:t>TIME</a:t>
+            </a:r>
+            <a:endParaRPr lang="en-US" sz="1100" dirty="0"/>
+          </a:p>
+        </p:txBody>
+      </p:sp>
+      <p:sp>
+        <p:nvSpPr>
+          <p:cNvPr id="9" name="Text 7"/>
+          <p:cNvSpPr txBox="1"/>
+          <p:nvPr/>
+        </p:nvSpPr>
+        <p:spPr>
+          <a:xfrm>
+            <a:off x="4572000" y="2029968"/>
+            <a:ext cx="3063240" cy="658368"/>
+          </a:xfrm>
+          <a:prstGeom prst="rect">
+            <a:avLst/>
+          </a:prstGeom>
+          <a:noFill/>
+          <a:ln/>
+        </p:spPr>
+        <p:txBody>
+          <a:bodyPr wrap="square" lIns="0" tIns="0" rIns="0" bIns="0" rtlCol="0" anchor="ctr"/>
+          <a:lstStyle/>
+          <a:p>
+            <a:pPr indent="0" marL="0">
+              <a:buNone/>
+            </a:pPr>
+            <a:r>
+              <a:rPr lang="en-US" sz="3400" b="1" dirty="0">
+                <a:solidFill>
+                  <a:srgbClr val="E2E8F0"/>
+                </a:solidFill>
+              </a:rPr>
+              <a:t>Days to 20s</a:t>
+            </a:r>
+            <a:endParaRPr lang="en-US" sz="3400" dirty="0"/>
+          </a:p>
+        </p:txBody>
+      </p:sp>
+      <p:sp>
+        <p:nvSpPr>
+          <p:cNvPr id="10" name="Text 8"/>
+          <p:cNvSpPr txBox="1"/>
+          <p:nvPr/>
+        </p:nvSpPr>
+        <p:spPr>
+          <a:xfrm>
+            <a:off x="4572000" y="2706624"/>
+            <a:ext cx="3063240" cy="292608"/>
+          </a:xfrm>
+          <a:prstGeom prst="rect">
+            <a:avLst/>
+          </a:prstGeom>
+          <a:noFill/>
+          <a:ln/>
+        </p:spPr>
+        <p:txBody>
+          <a:bodyPr wrap="square" lIns="0" tIns="0" rIns="0" bIns="0" rtlCol="0" anchor="ctr"/>
+          <a:lstStyle/>
+          <a:p>
+            <a:pPr indent="0" marL="0">
+              <a:buNone/>
+            </a:pPr>
+            <a:r>
+              <a:rPr lang="en-US" sz="1200" dirty="0">
+                <a:solidFill>
+                  <a:srgbClr val="64748B"/>
+                </a:solidFill>
+              </a:rPr>
+              <a:t>three people to none</a:t>
+            </a:r>
+            <a:endParaRPr lang="en-US" sz="1200" dirty="0"/>
+          </a:p>
+        </p:txBody>
+      </p:sp>
+      <p:sp>
+        <p:nvSpPr>
+          <p:cNvPr id="11" name="stat-On one part"/>
+          <p:cNvSpPr/>
+          <p:nvPr/>
+        </p:nvSpPr>
+        <p:spPr>
+          <a:xfrm>
+            <a:off x="8046720" y="1554480"/>
+            <a:ext cx="3474720" cy="1600200"/>
+          </a:xfrm>
+          <a:prstGeom prst="roundRect">
+            <a:avLst>
+              <a:gd name="adj" fmla="val 4571"/>
+            </a:avLst>
+          </a:prstGeom>
+          <a:solidFill>
+            <a:srgbClr val="0F172A"/>
+          </a:solidFill>
+          <a:ln w="12700">
+            <a:solidFill>
+              <a:srgbClr val="1E293B"/>
+            </a:solidFill>
+            <a:prstDash val="solid"/>
+          </a:ln>
+        </p:spPr>
+      </p:sp>
+      <p:sp>
+        <p:nvSpPr>
+          <p:cNvPr id="12" name="Text 10"/>
+          <p:cNvSpPr txBox="1"/>
+          <p:nvPr/>
+        </p:nvSpPr>
+        <p:spPr>
+          <a:xfrm>
+            <a:off x="8275320" y="1719072"/>
+            <a:ext cx="3017520" cy="274320"/>
+          </a:xfrm>
+          <a:prstGeom prst="rect">
+            <a:avLst/>
+          </a:prstGeom>
+          <a:noFill/>
+          <a:ln/>
+        </p:spPr>
+        <p:txBody>
+          <a:bodyPr wrap="square" lIns="0" tIns="0" rIns="0" bIns="0" rtlCol="0" anchor="ctr"/>
+          <a:lstStyle/>
+          <a:p>
+            <a:pPr indent="0" marL="0">
+              <a:buNone/>
+            </a:pPr>
+            <a:r>
+              <a:rPr lang="en-US" sz="1100" spc="100" kern="0" dirty="0">
+                <a:solidFill>
+                  <a:srgbClr val="64748B"/>
+                </a:solidFill>
+              </a:rPr>
+              <a:t>ON ONE PART</a:t>
+            </a:r>
+            <a:endParaRPr lang="en-US" sz="1100" dirty="0"/>
+          </a:p>
+        </p:txBody>
+      </p:sp>
+      <p:sp>
+        <p:nvSpPr>
+          <p:cNvPr id="13" name="Text 11"/>
+          <p:cNvSpPr txBox="1"/>
+          <p:nvPr/>
+        </p:nvSpPr>
+        <p:spPr>
+          <a:xfrm>
+            <a:off x="8275320" y="2029968"/>
+            <a:ext cx="3017520" cy="658368"/>
+          </a:xfrm>
+          <a:prstGeom prst="rect">
+            <a:avLst/>
+          </a:prstGeom>
+          <a:noFill/>
+          <a:ln/>
+        </p:spPr>
+        <p:txBody>
+          <a:bodyPr wrap="square" lIns="0" tIns="0" rIns="0" bIns="0" rtlCol="0" anchor="ctr"/>
+          <a:lstStyle/>
+          <a:p>
+            <a:pPr indent="0" marL="0">
+              <a:buNone/>
+            </a:pPr>
+            <a:r>
+              <a:rPr lang="en-US" sz="3400" b="1" dirty="0">
+                <a:solidFill>
+                  <a:srgbClr val="E2E8F0"/>
+                </a:solidFill>
+              </a:rPr>
+              <a:t>EUR 9.06M</a:t>
+            </a:r>
+            <a:endParaRPr lang="en-US" sz="3400" dirty="0"/>
+          </a:p>
+        </p:txBody>
+      </p:sp>
+      <p:sp>
+        <p:nvSpPr>
+          <p:cNvPr id="14" name="Text 12"/>
+          <p:cNvSpPr txBox="1"/>
+          <p:nvPr/>
+        </p:nvSpPr>
+        <p:spPr>
+          <a:xfrm>
+            <a:off x="8275320" y="2706624"/>
+            <a:ext cx="3017520" cy="292608"/>
+          </a:xfrm>
+          <a:prstGeom prst="rect">
+            <a:avLst/>
+          </a:prstGeom>
+          <a:noFill/>
+          <a:ln/>
+        </p:spPr>
+        <p:txBody>
+          <a:bodyPr wrap="square" lIns="0" tIns="0" rIns="0" bIns="0" rtlCol="0" anchor="ctr"/>
+          <a:lstStyle/>
+          <a:p>
+            <a:pPr indent="0" marL="0">
+              <a:buNone/>
+            </a:pPr>
+            <a:r>
+              <a:rPr lang="en-US" sz="1200" dirty="0">
+                <a:solidFill>
+                  <a:srgbClr val="64748B"/>
+                </a:solidFill>
+              </a:rPr>
+              <a:t>annual revenue protected</a:t>
+            </a:r>
+            <a:endParaRPr lang="en-US" sz="1200" dirty="0"/>
+          </a:p>
+        </p:txBody>
+      </p:sp>
+      <p:sp>
+        <p:nvSpPr>
+          <p:cNvPr id="15" name="market"/>
+          <p:cNvSpPr/>
+          <p:nvPr/>
+        </p:nvSpPr>
+        <p:spPr>
+          <a:xfrm>
+            <a:off x="640080" y="3429000"/>
+            <a:ext cx="5486400" cy="2194560"/>
+          </a:xfrm>
+          <a:prstGeom prst="roundRect">
+            <a:avLst>
+              <a:gd name="adj" fmla="val 3333"/>
+            </a:avLst>
+          </a:prstGeom>
+          <a:solidFill>
+            <a:srgbClr val="0F172A"/>
+          </a:solidFill>
+          <a:ln w="12700">
+            <a:solidFill>
+              <a:srgbClr val="1E293B"/>
+            </a:solidFill>
+            <a:prstDash val="solid"/>
+          </a:ln>
+        </p:spPr>
+      </p:sp>
+      <p:sp>
+        <p:nvSpPr>
+          <p:cNvPr id="16" name="Text 14"/>
+          <p:cNvSpPr txBox="1"/>
+          <p:nvPr/>
+        </p:nvSpPr>
+        <p:spPr>
+          <a:xfrm>
+            <a:off x="914400" y="3639312"/>
+            <a:ext cx="4937760" cy="274320"/>
+          </a:xfrm>
+          <a:prstGeom prst="rect">
+            <a:avLst/>
+          </a:prstGeom>
+          <a:noFill/>
+          <a:ln/>
+        </p:spPr>
+        <p:txBody>
+          <a:bodyPr wrap="square" lIns="0" tIns="0" rIns="0" bIns="0" rtlCol="0" anchor="ctr"/>
+          <a:lstStyle/>
+          <a:p>
+            <a:pPr indent="0" marL="0">
+              <a:buNone/>
+            </a:pPr>
+            <a:r>
+              <a:rPr lang="en-US" sz="1400" b="1" dirty="0">
+                <a:solidFill>
+                  <a:srgbClr val="6366F1"/>
+                </a:solidFill>
+              </a:rPr>
+              <a:t>The category exists</a:t>
+            </a:r>
+            <a:endParaRPr lang="en-US" sz="1400" dirty="0"/>
+          </a:p>
+        </p:txBody>
+      </p:sp>
+      <p:sp>
+        <p:nvSpPr>
+          <p:cNvPr id="17" name="Text 15"/>
+          <p:cNvSpPr txBox="1"/>
+          <p:nvPr/>
+        </p:nvSpPr>
+        <p:spPr>
+          <a:xfrm>
+            <a:off x="914400" y="3977640"/>
+            <a:ext cx="4937760" cy="1554480"/>
+          </a:xfrm>
+          <a:prstGeom prst="rect">
+            <a:avLst/>
+          </a:prstGeom>
+          <a:noFill/>
+          <a:ln/>
+        </p:spPr>
+        <p:txBody>
+          <a:bodyPr wrap="square" lIns="0" tIns="0" rIns="0" bIns="0" rtlCol="0" anchor="ctr"/>
+          <a:lstStyle/>
+          <a:p>
+            <a:pPr indent="0" marL="0">
+              <a:lnSpc>
+                <a:spcPct val="130000"/>
+              </a:lnSpc>
+              <a:buNone/>
+            </a:pPr>
+            <a:r>
+              <a:rPr lang="en-US" sz="1300" dirty="0">
+                <a:solidFill>
+                  <a:srgbClr val="94A3B8"/>
+                </a:solidFill>
+              </a:rPr>
+              <a:t>SiliconExpert, Z2Data and IHS sell obsolescence data today, and manufacturers employ obsolescence managers. That is the proof of willingness to pay.</a:t>
+            </a:r>
+            <a:endParaRPr lang="en-US" sz="1300" dirty="0"/>
+          </a:p>
+          <a:p>
+            <a:pPr indent="0" marL="0">
+              <a:lnSpc>
+                <a:spcPct val="130000"/>
+              </a:lnSpc>
+              <a:buNone/>
+            </a:pPr>
+            <a:endParaRPr lang="en-US" sz="1300" dirty="0"/>
+          </a:p>
+          <a:p>
+            <a:pPr indent="0" marL="0">
+              <a:lnSpc>
+                <a:spcPct val="130000"/>
+              </a:lnSpc>
+              <a:buNone/>
+            </a:pPr>
+            <a:r>
+              <a:rPr lang="en-US" sz="1300" dirty="0">
+                <a:solidFill>
+                  <a:srgbClr val="94A3B8"/>
+                </a:solidFill>
+              </a:rPr>
+              <a:t>Every one of them is a database you search. This is the first that reads the incoming notice and tells you what breaks.</a:t>
+            </a:r>
+            <a:endParaRPr lang="en-US" sz="1300" dirty="0"/>
+          </a:p>
+        </p:txBody>
+      </p:sp>
+      <p:sp>
+        <p:nvSpPr>
+          <p:cNvPr id="18" name="stack"/>
+          <p:cNvSpPr/>
+          <p:nvPr/>
+        </p:nvSpPr>
+        <p:spPr>
+          <a:xfrm>
+            <a:off x="6492240" y="3429000"/>
+            <a:ext cx="5029200" cy="2194560"/>
+          </a:xfrm>
+          <a:prstGeom prst="roundRect">
+            <a:avLst>
+              <a:gd name="adj" fmla="val 3333"/>
+            </a:avLst>
+          </a:prstGeom>
+          <a:solidFill>
+            <a:srgbClr val="0F172A"/>
+          </a:solidFill>
+          <a:ln w="12700">
+            <a:solidFill>
+              <a:srgbClr val="1E293B"/>
+            </a:solidFill>
+            <a:prstDash val="solid"/>
+          </a:ln>
+        </p:spPr>
+      </p:sp>
+      <p:sp>
+        <p:nvSpPr>
+          <p:cNvPr id="19" name="Text 17"/>
+          <p:cNvSpPr txBox="1"/>
+          <p:nvPr/>
+        </p:nvSpPr>
+        <p:spPr>
+          <a:xfrm>
+            <a:off x="6766560" y="3639312"/>
+            <a:ext cx="4480560" cy="274320"/>
+          </a:xfrm>
+          <a:prstGeom prst="rect">
+            <a:avLst/>
+          </a:prstGeom>
+          <a:noFill/>
+          <a:ln/>
+        </p:spPr>
+        <p:txBody>
+          <a:bodyPr wrap="square" lIns="0" tIns="0" rIns="0" bIns="0" rtlCol="0" anchor="ctr"/>
+          <a:lstStyle/>
+          <a:p>
+            <a:pPr indent="0" marL="0">
+              <a:buNone/>
+            </a:pPr>
+            <a:r>
+              <a:rPr lang="en-US" sz="1400" b="1" dirty="0">
+                <a:solidFill>
+                  <a:srgbClr val="6366F1"/>
+                </a:solidFill>
+              </a:rPr>
+              <a:t>Built on</a:t>
+            </a:r>
+            <a:endParaRPr lang="en-US" sz="1400" dirty="0"/>
+          </a:p>
+        </p:txBody>
+      </p:sp>
+      <p:sp>
+        <p:nvSpPr>
+          <p:cNvPr id="20" name="Text 18"/>
+          <p:cNvSpPr txBox="1"/>
+          <p:nvPr/>
+        </p:nvSpPr>
+        <p:spPr>
+          <a:xfrm>
+            <a:off x="6766560" y="3977640"/>
+            <a:ext cx="4480560" cy="1554480"/>
+          </a:xfrm>
+          <a:prstGeom prst="rect">
+            <a:avLst/>
+          </a:prstGeom>
+          <a:noFill/>
+          <a:ln/>
+        </p:spPr>
+        <p:txBody>
+          <a:bodyPr wrap="square" rtlCol="0" anchor="ctr"/>
+          <a:lstStyle/>
+          <a:p>
+            <a:pPr indent="0" marL="0">
+              <a:lnSpc>
+                <a:spcPct val="135000"/>
+              </a:lnSpc>
+              <a:buNone/>
+            </a:pPr>
+            <a:r>
+              <a:rPr lang="en-US" sz="1300" b="1" dirty="0">
+                <a:solidFill>
+                  <a:schemeClr val="tx1"/>
+                </a:solidFill>
+              </a:rPr>
+              <a:t>AMD Token Factory  </a:t>
+            </a:r>
+            <a:pPr indent="0" marL="0">
+              <a:lnSpc>
+                <a:spcPct val="135000"/>
+              </a:lnSpc>
+              <a:buNone/>
+            </a:pPr>
+            <a:r>
+              <a:rPr lang="en-US" sz="1300" dirty="0">
+                <a:solidFill>
+                  <a:srgbClr val="94A3B8"/>
+                </a:solidFill>
+              </a:rPr>
+              <a:t>— every model call, on AMD GPUs</a:t>
+            </a:r>
+            <a:endParaRPr lang="en-US" sz="1300" dirty="0"/>
+          </a:p>
+          <a:p>
+            <a:pPr indent="0" marL="0">
+              <a:lnSpc>
+                <a:spcPct val="135000"/>
+              </a:lnSpc>
+              <a:buNone/>
+            </a:pPr>
+            <a:r>
+              <a:rPr lang="en-US" sz="1300" b="1" dirty="0">
+                <a:solidFill>
+                  <a:schemeClr val="tx1"/>
+                </a:solidFill>
+              </a:rPr>
+              <a:t>Evolus  </a:t>
+            </a:r>
+            <a:pPr indent="0" marL="0">
+              <a:lnSpc>
+                <a:spcPct val="135000"/>
+              </a:lnSpc>
+              <a:buNone/>
+            </a:pPr>
+            <a:r>
+              <a:rPr lang="en-US" sz="1300" dirty="0">
+                <a:solidFill>
+                  <a:srgbClr val="94A3B8"/>
+                </a:solidFill>
+              </a:rPr>
+              <a:t>— agent on that same AMD endpoint, plus translate, doc-structure and email</a:t>
+            </a:r>
+            <a:endParaRPr lang="en-US" sz="1300" dirty="0"/>
+          </a:p>
+          <a:p>
+            <a:pPr indent="0" marL="0">
+              <a:lnSpc>
+                <a:spcPct val="135000"/>
+              </a:lnSpc>
+              <a:buNone/>
+            </a:pPr>
+            <a:r>
+              <a:rPr lang="en-US" sz="1300" b="1" dirty="0">
+                <a:solidFill>
+                  <a:schemeClr val="tx1"/>
+                </a:solidFill>
+              </a:rPr>
+              <a:t>Impact engine  </a:t>
+            </a:r>
+            <a:pPr indent="0" marL="0">
+              <a:lnSpc>
+                <a:spcPct val="135000"/>
+              </a:lnSpc>
+              <a:buNone/>
+            </a:pPr>
+            <a:r>
+              <a:rPr lang="en-US" sz="1300" dirty="0">
+                <a:solidFill>
+                  <a:srgbClr val="94A3B8"/>
+                </a:solidFill>
+              </a:rPr>
+              <a:t>— TypeScript, deterministic, auditable</a:t>
+            </a:r>
+            <a:endParaRPr lang="en-US" sz="1300" dirty="0"/>
+          </a:p>
+        </p:txBody>
+      </p:sp>
+      <p:sp>
+        <p:nvSpPr>
+          <p:cNvPr id="25" name="Slide Number Placeholder 0"/>
+          <p:cNvSpPr>
+            <a:spLocks noGrp="1"/>
+          </p:cNvSpPr>
+          <p:nvPr>
+            <p:ph type="sldNum" sz="quarter" idx="4294967295"/>
+          </p:nvPr>
+        </p:nvSpPr>
+        <p:spPr>
+          <a:xfrm>
+            <a:off x="11384280" y="6355080"/>
+            <a:ext cx="800000" cy="300000"/>
+          </a:xfrm>
+          <a:prstGeom prst="rect">
+            <a:avLst/>
+          </a:prstGeom>
+          <a:extLst>
+            <a:ext uri="{C572A759-6A51-4108-AA02-DFA0A04FC94B}">
+              <ma14:wrappingTextBoxFlag xmlns:ma14="http://schemas.microsoft.com/office/mac/drawingml/2011/main" val="0"/>
+            </a:ext>
+          </a:extLst>
+        </p:spPr>
+        <p:txBody>
+          <a:bodyPr/>
+          <a:lstStyle>
+            <a:lvl1pPr>
+              <a:defRPr sz="1000">
+                <a:solidFill>
+                  <a:srgbClr val="64748B"/>
+                </a:solidFill>
+                <a:latin typeface="Arial"/>
+                <a:ea typeface="Arial"/>
+                <a:cs typeface="Arial"/>
+              </a:defRPr>
+            </a:lvl1pPr>
+          </a:lstStyle>
+          <a:p>
+            <a:pPr algn="l"/>
+            <a:fld id="{F7021451-1387-4CA6-816F-3879F97B5CBC}" type="slidenum">
+              <a:rPr b="0" lang="en-US"/>
+              <a:t>10</a:t>
+            </a:fld>
+            <a:endParaRPr lang="en-US"/>
           </a:p>
         </p:txBody>
       </p:sp>
@@ -2226,11 +3138,11 @@
             </a:avLst>
           </a:prstGeom>
           <a:solidFill>
-            <a:srgbClr val="161A21"/>
+            <a:srgbClr val="0F172A"/>
           </a:solidFill>
           <a:ln w="12700">
             <a:solidFill>
-              <a:srgbClr val="242A35"/>
+              <a:srgbClr val="1E293B"/>
             </a:solidFill>
             <a:prstDash val="solid"/>
           </a:ln>
@@ -2263,7 +3175,7 @@
             <a:r>
               <a:rPr lang="en-US" sz="1300" b="1" dirty="0">
                 <a:solidFill>
-                  <a:srgbClr val="F0B429"/>
+                  <a:srgbClr val="6366F1"/>
                 </a:solidFill>
                 <a:latin typeface="Courier New" pitchFamily="34" charset="0"/>
                 <a:ea typeface="Courier New" pitchFamily="34" charset="-122"/>
@@ -2305,7 +3217,7 @@
             <a:r>
               <a:rPr lang="en-US" sz="1300" dirty="0">
                 <a:solidFill>
-                  <a:srgbClr val="9AA3B2"/>
+                  <a:srgbClr val="94A3B8"/>
                 </a:solidFill>
                 <a:latin typeface="Courier New" pitchFamily="34" charset="0"/>
                 <a:ea typeface="Courier New" pitchFamily="34" charset="-122"/>
@@ -2325,7 +3237,7 @@
             <a:r>
               <a:rPr lang="en-US" sz="1300" dirty="0">
                 <a:solidFill>
-                  <a:srgbClr val="9AA3B2"/>
+                  <a:srgbClr val="94A3B8"/>
                 </a:solidFill>
                 <a:latin typeface="Courier New" pitchFamily="34" charset="0"/>
                 <a:ea typeface="Courier New" pitchFamily="34" charset="-122"/>
@@ -2354,7 +3266,7 @@
             <a:r>
               <a:rPr lang="en-US" sz="1300" dirty="0">
                 <a:solidFill>
-                  <a:srgbClr val="9AA3B2"/>
+                  <a:srgbClr val="94A3B8"/>
                 </a:solidFill>
                 <a:latin typeface="Courier New" pitchFamily="34" charset="0"/>
                 <a:ea typeface="Courier New" pitchFamily="34" charset="-122"/>
@@ -2374,7 +3286,7 @@
             <a:r>
               <a:rPr lang="en-US" sz="1300" dirty="0">
                 <a:solidFill>
-                  <a:srgbClr val="9AA3B2"/>
+                  <a:srgbClr val="94A3B8"/>
                 </a:solidFill>
                 <a:latin typeface="Courier New" pitchFamily="34" charset="0"/>
                 <a:ea typeface="Courier New" pitchFamily="34" charset="-122"/>
@@ -2403,7 +3315,7 @@
             <a:r>
               <a:rPr lang="en-US" sz="1300" dirty="0">
                 <a:solidFill>
-                  <a:srgbClr val="9AA3B2"/>
+                  <a:srgbClr val="94A3B8"/>
                 </a:solidFill>
                 <a:latin typeface="Courier New" pitchFamily="34" charset="0"/>
                 <a:ea typeface="Courier New" pitchFamily="34" charset="-122"/>
@@ -2626,7 +3538,7 @@
             <a:r>
               <a:rPr lang="en-US" sz="1600" i="1" dirty="0">
                 <a:solidFill>
-                  <a:srgbClr val="F0B429"/>
+                  <a:srgbClr val="6366F1"/>
                 </a:solidFill>
               </a:rPr>
               <a:t>Days of work, across several people, in spreadsheets.</a:t>
@@ -2665,7 +3577,7 @@
             <a:lvl1pPr>
               <a:defRPr sz="1000">
                 <a:solidFill>
-                  <a:srgbClr val="6B7280"/>
+                  <a:srgbClr val="64748B"/>
                 </a:solidFill>
                 <a:latin typeface="Arial"/>
                 <a:ea typeface="Arial"/>
@@ -2763,11 +3675,11 @@
             </a:avLst>
           </a:prstGeom>
           <a:solidFill>
-            <a:srgbClr val="161A21"/>
+            <a:srgbClr val="0F172A"/>
           </a:solidFill>
           <a:ln w="12700">
             <a:solidFill>
-              <a:srgbClr val="242A35"/>
+              <a:srgbClr val="1E293B"/>
             </a:solidFill>
             <a:prstDash val="solid"/>
           </a:ln>
@@ -2800,7 +3712,7 @@
             <a:r>
               <a:rPr lang="en-US" sz="1100" spc="100" kern="0" dirty="0">
                 <a:solidFill>
-                  <a:srgbClr val="6B7280"/>
+                  <a:srgbClr val="64748B"/>
                 </a:solidFill>
               </a:rPr>
               <a:t>LAST BUY IN</a:t>
@@ -2836,7 +3748,7 @@
             <a:r>
               <a:rPr lang="en-US" sz="3400" b="1" dirty="0">
                 <a:solidFill>
-                  <a:srgbClr val="E6E9EF"/>
+                  <a:srgbClr val="E2E8F0"/>
                 </a:solidFill>
               </a:rPr>
               <a:t>34 days</a:t>
@@ -2862,11 +3774,11 @@
             </a:avLst>
           </a:prstGeom>
           <a:solidFill>
-            <a:srgbClr val="161A21"/>
+            <a:srgbClr val="0F172A"/>
           </a:solidFill>
           <a:ln w="12700">
             <a:solidFill>
-              <a:srgbClr val="242A35"/>
+              <a:srgbClr val="1E293B"/>
             </a:solidFill>
             <a:prstDash val="solid"/>
           </a:ln>
@@ -2899,7 +3811,7 @@
             <a:r>
               <a:rPr lang="en-US" sz="1100" spc="100" kern="0" dirty="0">
                 <a:solidFill>
-                  <a:srgbClr val="6B7280"/>
+                  <a:srgbClr val="64748B"/>
                 </a:solidFill>
               </a:rPr>
               <a:t>STOCK RUNWAY</a:t>
@@ -2935,7 +3847,7 @@
             <a:r>
               <a:rPr lang="en-US" sz="3400" b="1" dirty="0">
                 <a:solidFill>
-                  <a:srgbClr val="F0616D"/>
+                  <a:srgbClr val="EF4444"/>
                 </a:solidFill>
               </a:rPr>
               <a:t>4.7 wk</a:t>
@@ -2971,7 +3883,7 @@
             <a:r>
               <a:rPr lang="en-US" sz="1200" dirty="0">
                 <a:solidFill>
-                  <a:srgbClr val="6B7280"/>
+                  <a:srgbClr val="64748B"/>
                 </a:solidFill>
               </a:rPr>
               <a:t>lead time 26 wk</a:t>
@@ -2997,11 +3909,11 @@
             </a:avLst>
           </a:prstGeom>
           <a:solidFill>
-            <a:srgbClr val="161A21"/>
+            <a:srgbClr val="0F172A"/>
           </a:solidFill>
           <a:ln w="12700">
             <a:solidFill>
-              <a:srgbClr val="242A35"/>
+              <a:srgbClr val="1E293B"/>
             </a:solidFill>
             <a:prstDash val="solid"/>
           </a:ln>
@@ -3034,7 +3946,7 @@
             <a:r>
               <a:rPr lang="en-US" sz="1100" spc="100" kern="0" dirty="0">
                 <a:solidFill>
-                  <a:srgbClr val="6B7280"/>
+                  <a:srgbClr val="64748B"/>
                 </a:solidFill>
               </a:rPr>
               <a:t>MUST BUY</a:t>
@@ -3070,7 +3982,7 @@
             <a:r>
               <a:rPr lang="en-US" sz="3400" b="1" dirty="0">
                 <a:solidFill>
-                  <a:srgbClr val="E6E9EF"/>
+                  <a:srgbClr val="E2E8F0"/>
                 </a:solidFill>
               </a:rPr>
               <a:t>504,798</a:t>
@@ -3106,7 +4018,7 @@
             <a:r>
               <a:rPr lang="en-US" sz="1200" dirty="0">
                 <a:solidFill>
-                  <a:srgbClr val="6B7280"/>
+                  <a:srgbClr val="64748B"/>
                 </a:solidFill>
               </a:rPr>
               <a:t>EUR 1,433,626</a:t>
@@ -3132,11 +4044,11 @@
             </a:avLst>
           </a:prstGeom>
           <a:solidFill>
-            <a:srgbClr val="161A21"/>
+            <a:srgbClr val="0F172A"/>
           </a:solidFill>
           <a:ln w="12700">
             <a:solidFill>
-              <a:srgbClr val="242A35"/>
+              <a:srgbClr val="1E293B"/>
             </a:solidFill>
             <a:prstDash val="solid"/>
           </a:ln>
@@ -3169,7 +4081,7 @@
             <a:r>
               <a:rPr lang="en-US" sz="1100" spc="100" kern="0" dirty="0">
                 <a:solidFill>
-                  <a:srgbClr val="6B7280"/>
+                  <a:srgbClr val="64748B"/>
                 </a:solidFill>
               </a:rPr>
               <a:t>REVENUE AT RISK</a:t>
@@ -3205,7 +4117,7 @@
             <a:r>
               <a:rPr lang="en-US" sz="2700" b="1" dirty="0">
                 <a:solidFill>
-                  <a:srgbClr val="E6E9EF"/>
+                  <a:srgbClr val="E2E8F0"/>
                 </a:solidFill>
               </a:rPr>
               <a:t>EUR 9.06M</a:t>
@@ -3241,7 +4153,7 @@
             <a:r>
               <a:rPr lang="en-US" sz="1200" dirty="0">
                 <a:solidFill>
-                  <a:srgbClr val="6B7280"/>
+                  <a:srgbClr val="64748B"/>
                 </a:solidFill>
               </a:rPr>
               <a:t>per year</a:t>
@@ -3267,11 +4179,11 @@
             </a:avLst>
           </a:prstGeom>
           <a:solidFill>
-            <a:srgbClr val="161A21"/>
+            <a:srgbClr val="0F172A"/>
           </a:solidFill>
           <a:ln w="12700">
             <a:solidFill>
-              <a:srgbClr val="242A35"/>
+              <a:srgbClr val="1E293B"/>
             </a:solidFill>
             <a:prstDash val="solid"/>
           </a:ln>
@@ -3307,7 +4219,7 @@
             <a:r>
               <a:rPr lang="en-US" sz="1700" b="1" dirty="0">
                 <a:solidFill>
-                  <a:srgbClr val="F0616D"/>
+                  <a:srgbClr val="EF4444"/>
                 </a:solidFill>
               </a:rPr>
               <a:t>They were already 21 weeks short — and nothing in their process would have said so.</a:t>
@@ -3324,7 +4236,7 @@
             <a:r>
               <a:rPr lang="en-US" sz="1700" dirty="0">
                 <a:solidFill>
-                  <a:srgbClr val="9AA3B2"/>
+                  <a:srgbClr val="94A3B8"/>
                 </a:solidFill>
               </a:rPr>
               <a:t>Four point seven weeks of cover against a twenty-six week lead time. That is true today, independently of the deadline in the letter.</a:t>
@@ -3360,7 +4272,7 @@
             <a:r>
               <a:rPr lang="en-US" sz="1300" dirty="0">
                 <a:solidFill>
-                  <a:srgbClr val="6B7280"/>
+                  <a:srgbClr val="64748B"/>
                 </a:solidFill>
               </a:rPr>
               <a:t>ADUM1201ARZ · dual-channel digital isolator · reaches 5 products through 3 assemblies by 7 distinct BOM paths</a:t>
@@ -3399,7 +4311,7 @@
             <a:lvl1pPr>
               <a:defRPr sz="1000">
                 <a:solidFill>
-                  <a:srgbClr val="6B7280"/>
+                  <a:srgbClr val="64748B"/>
                 </a:solidFill>
                 <a:latin typeface="Arial"/>
                 <a:ea typeface="Arial"/>
@@ -3497,11 +4409,11 @@
             </a:avLst>
           </a:prstGeom>
           <a:solidFill>
-            <a:srgbClr val="161A21"/>
+            <a:srgbClr val="0F172A"/>
           </a:solidFill>
           <a:ln w="12700">
             <a:solidFill>
-              <a:srgbClr val="242A35"/>
+              <a:srgbClr val="1E293B"/>
             </a:solidFill>
             <a:prstDash val="solid"/>
           </a:ln>
@@ -3534,7 +4446,7 @@
             <a:r>
               <a:rPr lang="en-US" sz="1000" b="1" spc="100" kern="0" dirty="0">
                 <a:solidFill>
-                  <a:srgbClr val="5AA9E6"/>
+                  <a:srgbClr val="A5B4FC"/>
                 </a:solidFill>
               </a:rPr>
               <a:t>EVOLUS</a:t>
@@ -3612,7 +4524,7 @@
             <a:r>
               <a:rPr lang="en-US" sz="1100" dirty="0">
                 <a:solidFill>
-                  <a:srgbClr val="6B7280"/>
+                  <a:srgbClr val="64748B"/>
                 </a:solidFill>
               </a:rPr>
               <a:t>the notice, in any language</a:t>
@@ -3638,11 +4550,11 @@
             </a:avLst>
           </a:prstGeom>
           <a:solidFill>
-            <a:srgbClr val="161A21"/>
+            <a:srgbClr val="0F172A"/>
           </a:solidFill>
           <a:ln w="12700">
             <a:solidFill>
-              <a:srgbClr val="242A35"/>
+              <a:srgbClr val="1E293B"/>
             </a:solidFill>
             <a:prstDash val="solid"/>
           </a:ln>
@@ -3675,7 +4587,7 @@
             <a:r>
               <a:rPr lang="en-US" sz="1000" b="1" spc="100" kern="0" dirty="0">
                 <a:solidFill>
-                  <a:srgbClr val="F0B429"/>
+                  <a:srgbClr val="6366F1"/>
                 </a:solidFill>
               </a:rPr>
               <a:t>ENGINE</a:t>
@@ -3753,7 +4665,7 @@
             <a:r>
               <a:rPr lang="en-US" sz="1100" dirty="0">
                 <a:solidFill>
-                  <a:srgbClr val="6B7280"/>
+                  <a:srgbClr val="64748B"/>
                 </a:solidFill>
               </a:rPr>
               <a:t>exact arithmetic, no model</a:t>
@@ -3779,11 +4691,11 @@
             </a:avLst>
           </a:prstGeom>
           <a:solidFill>
-            <a:srgbClr val="161A21"/>
+            <a:srgbClr val="0F172A"/>
           </a:solidFill>
           <a:ln w="12700">
             <a:solidFill>
-              <a:srgbClr val="242A35"/>
+              <a:srgbClr val="1E293B"/>
             </a:solidFill>
             <a:prstDash val="solid"/>
           </a:ln>
@@ -3816,7 +4728,7 @@
             <a:r>
               <a:rPr lang="en-US" sz="1000" b="1" spc="100" kern="0" dirty="0">
                 <a:solidFill>
-                  <a:srgbClr val="F0B429"/>
+                  <a:srgbClr val="EF4444"/>
                 </a:solidFill>
               </a:rPr>
               <a:t>AMD</a:t>
@@ -3894,7 +4806,7 @@
             <a:r>
               <a:rPr lang="en-US" sz="1100" dirty="0">
                 <a:solidFill>
-                  <a:srgbClr val="6B7280"/>
+                  <a:srgbClr val="64748B"/>
                 </a:solidFill>
               </a:rPr>
               <a:t>open model on AMD GPUs</a:t>
@@ -3920,11 +4832,11 @@
             </a:avLst>
           </a:prstGeom>
           <a:solidFill>
-            <a:srgbClr val="161A21"/>
+            <a:srgbClr val="0F172A"/>
           </a:solidFill>
           <a:ln w="12700">
             <a:solidFill>
-              <a:srgbClr val="242A35"/>
+              <a:srgbClr val="1E293B"/>
             </a:solidFill>
             <a:prstDash val="solid"/>
           </a:ln>
@@ -3957,7 +4869,7 @@
             <a:r>
               <a:rPr lang="en-US" sz="1000" b="1" spc="100" kern="0" dirty="0">
                 <a:solidFill>
-                  <a:srgbClr val="5AA9E6"/>
+                  <a:srgbClr val="A5B4FC"/>
                 </a:solidFill>
               </a:rPr>
               <a:t>EVOLUS</a:t>
@@ -4035,7 +4947,7 @@
             <a:r>
               <a:rPr lang="en-US" sz="1100" dirty="0">
                 <a:solidFill>
-                  <a:srgbClr val="6B7280"/>
+                  <a:srgbClr val="64748B"/>
                 </a:solidFill>
               </a:rPr>
               <a:t>cites the clause</a:t>
@@ -4061,11 +4973,11 @@
             </a:avLst>
           </a:prstGeom>
           <a:solidFill>
-            <a:srgbClr val="161A21"/>
+            <a:srgbClr val="0F172A"/>
           </a:solidFill>
           <a:ln w="12700">
             <a:solidFill>
-              <a:srgbClr val="242A35"/>
+              <a:srgbClr val="1E293B"/>
             </a:solidFill>
             <a:prstDash val="solid"/>
           </a:ln>
@@ -4098,7 +5010,7 @@
             <a:r>
               <a:rPr lang="en-US" sz="1000" b="1" spc="100" kern="0" dirty="0">
                 <a:solidFill>
-                  <a:srgbClr val="5AA9E6"/>
+                  <a:srgbClr val="A5B4FC"/>
                 </a:solidFill>
               </a:rPr>
               <a:t>EVOLUS</a:t>
@@ -4176,7 +5088,7 @@
             <a:r>
               <a:rPr lang="en-US" sz="1100" dirty="0">
                 <a:solidFill>
-                  <a:srgbClr val="6B7280"/>
+                  <a:srgbClr val="64748B"/>
                 </a:solidFill>
               </a:rPr>
               <a:t>nothing is sent</a:t>
@@ -4202,11 +5114,11 @@
             </a:avLst>
           </a:prstGeom>
           <a:solidFill>
-            <a:srgbClr val="161A21"/>
+            <a:srgbClr val="0F172A"/>
           </a:solidFill>
           <a:ln w="12700">
             <a:solidFill>
-              <a:srgbClr val="242A35"/>
+              <a:srgbClr val="1E293B"/>
             </a:solidFill>
             <a:prstDash val="solid"/>
           </a:ln>
@@ -4239,7 +5151,7 @@
             <a:r>
               <a:rPr lang="en-US" sz="1700" b="1" dirty="0">
                 <a:solidFill>
-                  <a:srgbClr val="3DD68C"/>
+                  <a:srgbClr val="10B981"/>
                 </a:solidFill>
               </a:rPr>
               <a:t>Then it stops.  </a:t>
@@ -4250,7 +5162,7 @@
             <a:r>
               <a:rPr lang="en-US" sz="1700" dirty="0">
                 <a:solidFill>
-                  <a:srgbClr val="9AA3B2"/>
+                  <a:srgbClr val="94A3B8"/>
                 </a:solidFill>
               </a:rPr>
               <a:t>A person commits the spend. The agent prepares the decision; it does not take it.</a:t>
@@ -4289,7 +5201,7 @@
             <a:lvl1pPr>
               <a:defRPr sz="1000">
                 <a:solidFill>
-                  <a:srgbClr val="6B7280"/>
+                  <a:srgbClr val="64748B"/>
                 </a:solidFill>
                 <a:latin typeface="Arial"/>
                 <a:ea typeface="Arial"/>
@@ -4387,11 +5299,11 @@
             </a:avLst>
           </a:prstGeom>
           <a:solidFill>
-            <a:srgbClr val="161A21"/>
+            <a:srgbClr val="0F172A"/>
           </a:solidFill>
           <a:ln w="12700">
             <a:solidFill>
-              <a:srgbClr val="242A35"/>
+              <a:srgbClr val="1E293B"/>
             </a:solidFill>
             <a:prstDash val="solid"/>
           </a:ln>
@@ -4463,7 +5375,7 @@
             <a:r>
               <a:rPr lang="en-US" sz="1200" dirty="0">
                 <a:solidFill>
-                  <a:srgbClr val="F0B429"/>
+                  <a:srgbClr val="6366F1"/>
                 </a:solidFill>
                 <a:latin typeface="Courier New" pitchFamily="34" charset="0"/>
                 <a:ea typeface="Courier New" pitchFamily="34" charset="-122"/>
@@ -4483,7 +5395,7 @@
             <a:r>
               <a:rPr lang="en-US" sz="1200" dirty="0">
                 <a:solidFill>
-                  <a:srgbClr val="F0B429"/>
+                  <a:srgbClr val="6366F1"/>
                 </a:solidFill>
                 <a:latin typeface="Courier New" pitchFamily="34" charset="0"/>
                 <a:ea typeface="Courier New" pitchFamily="34" charset="-122"/>
@@ -4525,7 +5437,7 @@
             <a:r>
               <a:rPr lang="en-US" sz="1300" dirty="0">
                 <a:solidFill>
-                  <a:srgbClr val="9AA3B2"/>
+                  <a:srgbClr val="94A3B8"/>
                 </a:solidFill>
               </a:rPr>
               <a:t>2 isolators per gate module x 3 modules per power board x 2 boards, plus 1 on the control board = 13 per unit.</a:t>
@@ -4657,11 +5569,11 @@
             </a:avLst>
           </a:prstGeom>
           <a:solidFill>
-            <a:srgbClr val="161A21"/>
+            <a:srgbClr val="0F172A"/>
           </a:solidFill>
           <a:ln w="12700">
             <a:solidFill>
-              <a:srgbClr val="242A35"/>
+              <a:srgbClr val="1E293B"/>
             </a:solidFill>
             <a:prstDash val="solid"/>
           </a:ln>
@@ -4694,7 +5606,7 @@
             <a:r>
               <a:rPr lang="en-US" sz="1700" i="1" dirty="0">
                 <a:solidFill>
-                  <a:srgbClr val="F0B429"/>
+                  <a:srgbClr val="6366F1"/>
                 </a:solidFill>
               </a:rPr>
               <a:t>The graph decides what is affected. The model reads, rules and writes. It is never asked for a number.</a:t>
@@ -4733,7 +5645,7 @@
             <a:lvl1pPr>
               <a:defRPr sz="1000">
                 <a:solidFill>
-                  <a:srgbClr val="6B7280"/>
+                  <a:srgbClr val="64748B"/>
                 </a:solidFill>
                 <a:latin typeface="Arial"/>
                 <a:ea typeface="Arial"/>
@@ -4831,11 +5743,11 @@
             </a:avLst>
           </a:prstGeom>
           <a:solidFill>
-            <a:srgbClr val="161A21"/>
+            <a:srgbClr val="0F172A"/>
           </a:solidFill>
           <a:ln w="12700">
             <a:solidFill>
-              <a:srgbClr val="242A35"/>
+              <a:srgbClr val="1E293B"/>
             </a:solidFill>
             <a:prstDash val="solid"/>
           </a:ln>
@@ -4868,7 +5780,7 @@
             <a:r>
               <a:rPr lang="en-US" sz="1300" b="1" dirty="0">
                 <a:solidFill>
-                  <a:srgbClr val="5AA9E6"/>
+                  <a:srgbClr val="A5B4FC"/>
                 </a:solidFill>
               </a:rPr>
               <a:t>It cites the clause</a:t>
@@ -4933,11 +5845,11 @@
             </a:avLst>
           </a:prstGeom>
           <a:solidFill>
-            <a:srgbClr val="161A21"/>
+            <a:srgbClr val="0F172A"/>
           </a:solidFill>
           <a:ln w="12700">
             <a:solidFill>
-              <a:srgbClr val="242A35"/>
+              <a:srgbClr val="1E293B"/>
             </a:solidFill>
             <a:prstDash val="solid"/>
           </a:ln>
@@ -4970,7 +5882,7 @@
             <a:r>
               <a:rPr lang="en-US" sz="1300" b="1" dirty="0">
                 <a:solidFill>
-                  <a:srgbClr val="3DD68C"/>
+                  <a:srgbClr val="10B981"/>
                 </a:solidFill>
               </a:rPr>
               <a:t>And it refuses what it cannot ground</a:t>
@@ -5130,7 +6042,7 @@
             <a:r>
               <a:rPr lang="en-US" sz="1600" i="1" dirty="0">
                 <a:solidFill>
-                  <a:srgbClr val="F0B429"/>
+                  <a:srgbClr val="6366F1"/>
                 </a:solidFill>
               </a:rPr>
               <a:t>That refusal is the feature. It is what you need before anything goes near a EUR 1.4M purchase order.</a:t>
@@ -5169,7 +6081,7 @@
             <a:lvl1pPr>
               <a:defRPr sz="1000">
                 <a:solidFill>
-                  <a:srgbClr val="6B7280"/>
+                  <a:srgbClr val="64748B"/>
                 </a:solidFill>
                 <a:latin typeface="Arial"/>
                 <a:ea typeface="Arial"/>
@@ -5252,7 +6164,7 @@
       </p:sp>
       <p:pic>
         <p:nvPicPr>
-          <p:cNvPr id="3" name="impact-screenshot" descr="G:\amd-hackathon\lastbuy\submission\screenshots\01-impact.jpg">    </p:cNvPr>
+          <p:cNvPr id="3" name="impact-screenshot" descr="G:\amd-hackathon\lastbuy\submission\screenshots\02-impact.jpg">    </p:cNvPr>
           <p:cNvPicPr>
             <a:picLocks noChangeAspect="1"/>
           </p:cNvPicPr>
@@ -5291,11 +6203,11 @@
             </a:avLst>
           </a:prstGeom>
           <a:solidFill>
-            <a:srgbClr val="161A21"/>
+            <a:srgbClr val="0F172A"/>
           </a:solidFill>
           <a:ln w="12700">
             <a:solidFill>
-              <a:srgbClr val="242A35"/>
+              <a:srgbClr val="1E293B"/>
             </a:solidFill>
             <a:prstDash val="solid"/>
           </a:ln>
@@ -5328,7 +6240,7 @@
             <a:r>
               <a:rPr lang="en-US" sz="1400" b="1" dirty="0">
                 <a:solidFill>
-                  <a:srgbClr val="F0B429"/>
+                  <a:srgbClr val="6366F1"/>
                 </a:solidFill>
               </a:rPr>
               <a:t>Four numbers, not a dashboard</a:t>
@@ -5367,7 +6279,7 @@
             <a:r>
               <a:rPr lang="en-US" sz="1200" dirty="0">
                 <a:solidFill>
-                  <a:srgbClr val="9AA3B2"/>
+                  <a:srgbClr val="94A3B8"/>
                 </a:solidFill>
               </a:rPr>
               <a:t>Days remaining, stock runway, quantity to buy, revenue exposed.</a:t>
@@ -5393,11 +6305,11 @@
             </a:avLst>
           </a:prstGeom>
           <a:solidFill>
-            <a:srgbClr val="161A21"/>
+            <a:srgbClr val="0F172A"/>
           </a:solidFill>
           <a:ln w="12700">
             <a:solidFill>
-              <a:srgbClr val="242A35"/>
+              <a:srgbClr val="1E293B"/>
             </a:solidFill>
             <a:prstDash val="solid"/>
           </a:ln>
@@ -5430,7 +6342,7 @@
             <a:r>
               <a:rPr lang="en-US" sz="1400" b="1" dirty="0">
                 <a:solidFill>
-                  <a:srgbClr val="F0B429"/>
+                  <a:srgbClr val="6366F1"/>
                 </a:solidFill>
               </a:rPr>
               <a:t>The path under every product</a:t>
@@ -5469,7 +6381,7 @@
             <a:r>
               <a:rPr lang="en-US" sz="1200" dirty="0">
                 <a:solidFill>
-                  <a:srgbClr val="9AA3B2"/>
+                  <a:srgbClr val="94A3B8"/>
                 </a:solidFill>
               </a:rPr>
               <a:t>ADUM1201ARZ to ASM-GATE-D to ASM-PWR-A to MD-7500. Check the 13 by hand.</a:t>
@@ -5495,11 +6407,11 @@
             </a:avLst>
           </a:prstGeom>
           <a:solidFill>
-            <a:srgbClr val="161A21"/>
+            <a:srgbClr val="0F172A"/>
           </a:solidFill>
           <a:ln w="12700">
             <a:solidFill>
-              <a:srgbClr val="242A35"/>
+              <a:srgbClr val="1E293B"/>
             </a:solidFill>
             <a:prstDash val="solid"/>
           </a:ln>
@@ -5532,7 +6444,7 @@
             <a:r>
               <a:rPr lang="en-US" sz="1400" b="1" dirty="0">
                 <a:solidFill>
-                  <a:srgbClr val="F0B429"/>
+                  <a:srgbClr val="6366F1"/>
                 </a:solidFill>
               </a:rPr>
               <a:t>Risk before any notice</a:t>
@@ -5571,7 +6483,7 @@
             <a:r>
               <a:rPr lang="en-US" sz="1200" dirty="0">
                 <a:solidFill>
-                  <a:srgbClr val="9AA3B2"/>
+                  <a:srgbClr val="94A3B8"/>
                 </a:solidFill>
               </a:rPr>
               <a:t>Parts scored from graph position and supplier history, left column.</a:t>
@@ -5610,7 +6522,7 @@
             <a:lvl1pPr>
               <a:defRPr sz="1000">
                 <a:solidFill>
-                  <a:srgbClr val="6B7280"/>
+                  <a:srgbClr val="64748B"/>
                 </a:solidFill>
                 <a:latin typeface="Arial"/>
                 <a:ea typeface="Arial"/>
@@ -5708,11 +6620,11 @@
             </a:avLst>
           </a:prstGeom>
           <a:solidFill>
-            <a:srgbClr val="161A21"/>
+            <a:srgbClr val="0F172A"/>
           </a:solidFill>
           <a:ln w="12700">
             <a:solidFill>
-              <a:srgbClr val="242A35"/>
+              <a:srgbClr val="1E293B"/>
             </a:solidFill>
             <a:prstDash val="solid"/>
           </a:ln>
@@ -5745,7 +6657,7 @@
             <a:r>
               <a:rPr lang="en-US" sz="1000" b="1" spc="100" kern="0" dirty="0">
                 <a:solidFill>
-                  <a:srgbClr val="5AA9E6"/>
+                  <a:srgbClr val="A5B4FC"/>
                 </a:solidFill>
               </a:rPr>
               <a:t>EVOLUS</a:t>
@@ -5817,7 +6729,7 @@
             <a:r>
               <a:rPr lang="en-US" sz="1300" dirty="0">
                 <a:solidFill>
-                  <a:srgbClr val="9AA3B2"/>
+                  <a:srgbClr val="94A3B8"/>
                 </a:solidFill>
               </a:rPr>
               <a:t>4.3 s</a:t>
@@ -5853,7 +6765,7 @@
             <a:r>
               <a:rPr lang="en-US" sz="1300" dirty="0">
                 <a:solidFill>
-                  <a:srgbClr val="6B7280"/>
+                  <a:srgbClr val="64748B"/>
                 </a:solidFill>
               </a:rPr>
               <a:t>2.06 credits</a:t>
@@ -5879,11 +6791,11 @@
             </a:avLst>
           </a:prstGeom>
           <a:solidFill>
-            <a:srgbClr val="161A21"/>
+            <a:srgbClr val="0F172A"/>
           </a:solidFill>
           <a:ln w="12700">
             <a:solidFill>
-              <a:srgbClr val="242A35"/>
+              <a:srgbClr val="1E293B"/>
             </a:solidFill>
             <a:prstDash val="solid"/>
           </a:ln>
@@ -5916,7 +6828,7 @@
             <a:r>
               <a:rPr lang="en-US" sz="1000" b="1" spc="100" kern="0" dirty="0">
                 <a:solidFill>
-                  <a:srgbClr val="5AA9E6"/>
+                  <a:srgbClr val="A5B4FC"/>
                 </a:solidFill>
               </a:rPr>
               <a:t>EVOLUS</a:t>
@@ -5988,7 +6900,7 @@
             <a:r>
               <a:rPr lang="en-US" sz="1300" dirty="0">
                 <a:solidFill>
-                  <a:srgbClr val="9AA3B2"/>
+                  <a:srgbClr val="94A3B8"/>
                 </a:solidFill>
               </a:rPr>
               <a:t>4.3 s</a:t>
@@ -6024,7 +6936,7 @@
             <a:r>
               <a:rPr lang="en-US" sz="1300" dirty="0">
                 <a:solidFill>
-                  <a:srgbClr val="6B7280"/>
+                  <a:srgbClr val="64748B"/>
                 </a:solidFill>
               </a:rPr>
               <a:t>2.79 credits</a:t>
@@ -6050,11 +6962,11 @@
             </a:avLst>
           </a:prstGeom>
           <a:solidFill>
-            <a:srgbClr val="161A21"/>
+            <a:srgbClr val="0F172A"/>
           </a:solidFill>
           <a:ln w="12700">
             <a:solidFill>
-              <a:srgbClr val="242A35"/>
+              <a:srgbClr val="1E293B"/>
             </a:solidFill>
             <a:prstDash val="solid"/>
           </a:ln>
@@ -6087,7 +6999,7 @@
             <a:r>
               <a:rPr lang="en-US" sz="1000" b="1" spc="100" kern="0" dirty="0">
                 <a:solidFill>
-                  <a:srgbClr val="6B7280"/>
+                  <a:srgbClr val="64748B"/>
                 </a:solidFill>
               </a:rPr>
               <a:t>ENGINE</a:t>
@@ -6159,7 +7071,7 @@
             <a:r>
               <a:rPr lang="en-US" sz="1300" dirty="0">
                 <a:solidFill>
-                  <a:srgbClr val="9AA3B2"/>
+                  <a:srgbClr val="94A3B8"/>
                 </a:solidFill>
               </a:rPr>
               <a:t>0.0 s</a:t>
@@ -6195,7 +7107,7 @@
             <a:r>
               <a:rPr lang="en-US" sz="1300" dirty="0">
                 <a:solidFill>
-                  <a:srgbClr val="6B7280"/>
+                  <a:srgbClr val="64748B"/>
                 </a:solidFill>
               </a:rPr>
               <a:t>free, local</a:t>
@@ -6221,11 +7133,11 @@
             </a:avLst>
           </a:prstGeom>
           <a:solidFill>
-            <a:srgbClr val="161A21"/>
+            <a:srgbClr val="0F172A"/>
           </a:solidFill>
           <a:ln w="12700">
             <a:solidFill>
-              <a:srgbClr val="242A35"/>
+              <a:srgbClr val="1E293B"/>
             </a:solidFill>
             <a:prstDash val="solid"/>
           </a:ln>
@@ -6258,7 +7170,7 @@
             <a:r>
               <a:rPr lang="en-US" sz="1000" b="1" spc="100" kern="0" dirty="0">
                 <a:solidFill>
-                  <a:srgbClr val="F0B429"/>
+                  <a:srgbClr val="6366F1"/>
                 </a:solidFill>
               </a:rPr>
               <a:t>AMD</a:t>
@@ -6330,7 +7242,7 @@
             <a:r>
               <a:rPr lang="en-US" sz="1300" dirty="0">
                 <a:solidFill>
-                  <a:srgbClr val="9AA3B2"/>
+                  <a:srgbClr val="94A3B8"/>
                 </a:solidFill>
               </a:rPr>
               <a:t>10.5 s</a:t>
@@ -6366,7 +7278,7 @@
             <a:r>
               <a:rPr lang="en-US" sz="1300" dirty="0">
                 <a:solidFill>
-                  <a:srgbClr val="6B7280"/>
+                  <a:srgbClr val="64748B"/>
                 </a:solidFill>
               </a:rPr>
               <a:t>$0.000118</a:t>
@@ -6392,11 +7304,11 @@
             </a:avLst>
           </a:prstGeom>
           <a:solidFill>
-            <a:srgbClr val="161A21"/>
+            <a:srgbClr val="0F172A"/>
           </a:solidFill>
           <a:ln w="12700">
             <a:solidFill>
-              <a:srgbClr val="242A35"/>
+              <a:srgbClr val="1E293B"/>
             </a:solidFill>
             <a:prstDash val="solid"/>
           </a:ln>
@@ -6429,7 +7341,7 @@
             <a:r>
               <a:rPr lang="en-US" sz="1000" b="1" spc="100" kern="0" dirty="0">
                 <a:solidFill>
-                  <a:srgbClr val="5AA9E6"/>
+                  <a:srgbClr val="A5B4FC"/>
                 </a:solidFill>
               </a:rPr>
               <a:t>EVOLUS</a:t>
@@ -6501,7 +7413,7 @@
             <a:r>
               <a:rPr lang="en-US" sz="1300" dirty="0">
                 <a:solidFill>
-                  <a:srgbClr val="9AA3B2"/>
+                  <a:srgbClr val="94A3B8"/>
                 </a:solidFill>
               </a:rPr>
               <a:t>3.7 s</a:t>
@@ -6537,7 +7449,7 @@
             <a:r>
               <a:rPr lang="en-US" sz="1300" dirty="0">
                 <a:solidFill>
-                  <a:srgbClr val="6B7280"/>
+                  <a:srgbClr val="64748B"/>
                 </a:solidFill>
               </a:rPr>
               <a:t>1.96 credits</a:t>
@@ -6563,11 +7475,11 @@
             </a:avLst>
           </a:prstGeom>
           <a:solidFill>
-            <a:srgbClr val="161A21"/>
+            <a:srgbClr val="0F172A"/>
           </a:solidFill>
           <a:ln w="12700">
             <a:solidFill>
-              <a:srgbClr val="242A35"/>
+              <a:srgbClr val="1E293B"/>
             </a:solidFill>
             <a:prstDash val="solid"/>
           </a:ln>
@@ -6600,7 +7512,7 @@
             <a:r>
               <a:rPr lang="en-US" sz="1000" b="1" spc="100" kern="0" dirty="0">
                 <a:solidFill>
-                  <a:srgbClr val="5AA9E6"/>
+                  <a:srgbClr val="A5B4FC"/>
                 </a:solidFill>
               </a:rPr>
               <a:t>EVOLUS</a:t>
@@ -6672,7 +7584,7 @@
             <a:r>
               <a:rPr lang="en-US" sz="1300" dirty="0">
                 <a:solidFill>
-                  <a:srgbClr val="9AA3B2"/>
+                  <a:srgbClr val="94A3B8"/>
                 </a:solidFill>
               </a:rPr>
               <a:t>3.0 s</a:t>
@@ -6708,7 +7620,7 @@
             <a:r>
               <a:rPr lang="en-US" sz="1300" dirty="0">
                 <a:solidFill>
-                  <a:srgbClr val="6B7280"/>
+                  <a:srgbClr val="64748B"/>
                 </a:solidFill>
               </a:rPr>
               <a:t>1.84 credits</a:t>
@@ -6734,11 +7646,11 @@
             </a:avLst>
           </a:prstGeom>
           <a:solidFill>
-            <a:srgbClr val="161A21"/>
+            <a:srgbClr val="0F172A"/>
           </a:solidFill>
           <a:ln w="12700">
             <a:solidFill>
-              <a:srgbClr val="242A35"/>
+              <a:srgbClr val="1E293B"/>
             </a:solidFill>
             <a:prstDash val="solid"/>
           </a:ln>
@@ -6771,7 +7683,7 @@
             <a:r>
               <a:rPr lang="en-US" sz="1000" b="1" spc="100" kern="0" dirty="0">
                 <a:solidFill>
-                  <a:srgbClr val="5AA9E6"/>
+                  <a:srgbClr val="A5B4FC"/>
                 </a:solidFill>
               </a:rPr>
               <a:t>EVOLUS</a:t>
@@ -6843,7 +7755,7 @@
             <a:r>
               <a:rPr lang="en-US" sz="1300" dirty="0">
                 <a:solidFill>
-                  <a:srgbClr val="9AA3B2"/>
+                  <a:srgbClr val="94A3B8"/>
                 </a:solidFill>
               </a:rPr>
               <a:t>10.8 s</a:t>
@@ -6879,7 +7791,7 @@
             <a:r>
               <a:rPr lang="en-US" sz="1300" dirty="0">
                 <a:solidFill>
-                  <a:srgbClr val="6B7280"/>
+                  <a:srgbClr val="64748B"/>
                 </a:solidFill>
               </a:rPr>
               <a:t>agent, on AMD</a:t>
@@ -6915,7 +7827,7 @@
             <a:r>
               <a:rPr lang="en-US" sz="1500" b="1" dirty="0">
                 <a:solidFill>
-                  <a:srgbClr val="F0B429"/>
+                  <a:srgbClr val="6366F1"/>
                 </a:solidFill>
               </a:rPr>
               <a:t>About 20 seconds, 9 Evolus credits and $0.00012.  </a:t>
@@ -6926,7 +7838,7 @@
             <a:r>
               <a:rPr lang="en-US" sz="1500" dirty="0">
                 <a:solidFill>
-                  <a:srgbClr val="9AA3B2"/>
+                  <a:srgbClr val="94A3B8"/>
                 </a:solidFill>
               </a:rPr>
               <a:t>A buyer deciding whether to run this on every incoming notice needs that number.</a:t>
@@ -6965,7 +7877,7 @@
             <a:lvl1pPr>
               <a:defRPr sz="1000">
                 <a:solidFill>
-                  <a:srgbClr val="6B7280"/>
+                  <a:srgbClr val="64748B"/>
                 </a:solidFill>
                 <a:latin typeface="Arial"/>
                 <a:ea typeface="Arial"/>
@@ -7040,34 +7952,58 @@
                   <a:schemeClr val="tx1"/>
                 </a:solidFill>
               </a:rPr>
-              <a:t>People already pay for this, badly</a:t>
+              <a:t>Drop in a notice you have never seen</a:t>
             </a:r>
             <a:endParaRPr lang="en-US" sz="3600" dirty="0"/>
           </a:p>
         </p:txBody>
       </p:sp>
-      <p:sp>
-        <p:nvSpPr>
-          <p:cNvPr id="3" name="stat-Per assessment"/>
+      <p:pic>
+        <p:nvPicPr>
+          <p:cNvPr id="3" name="inbox-screenshot" descr="G:\amd-hackathon\lastbuy\submission\screenshots\01-inbox.jpg">    </p:cNvPr>
+          <p:cNvPicPr>
+            <a:picLocks noChangeAspect="1"/>
+          </p:cNvPicPr>
+          <p:nvPr/>
+        </p:nvPicPr>
+        <p:blipFill>
+          <a:blip r:embed="rId1"/>
+          <a:stretch>
+            <a:fillRect/>
+          </a:stretch>
+        </p:blipFill>
+        <p:spPr>
+          <a:xfrm>
+            <a:off x="640080" y="1508760"/>
+            <a:ext cx="6766560" cy="4270248"/>
+          </a:xfrm>
+          <a:prstGeom prst="rect">
+            <a:avLst/>
+          </a:prstGeom>
+        </p:spPr>
+      </p:pic>
+      <p:sp>
+        <p:nvSpPr>
+          <p:cNvPr id="4" name="up-0"/>
           <p:cNvSpPr/>
           <p:nvPr/>
         </p:nvSpPr>
         <p:spPr>
           <a:xfrm>
-            <a:off x="640080" y="1554480"/>
-            <a:ext cx="3520440" cy="1600200"/>
+            <a:off x="7635240" y="1645920"/>
+            <a:ext cx="3886200" cy="1298448"/>
           </a:xfrm>
           <a:prstGeom prst="roundRect">
             <a:avLst>
-              <a:gd name="adj" fmla="val 4571"/>
+              <a:gd name="adj" fmla="val 5634"/>
             </a:avLst>
           </a:prstGeom>
           <a:solidFill>
-            <a:srgbClr val="161A21"/>
+            <a:srgbClr val="0F172A"/>
           </a:solidFill>
           <a:ln w="12700">
             <a:solidFill>
-              <a:srgbClr val="242A35"/>
+              <a:srgbClr val="1E293B"/>
             </a:solidFill>
             <a:prstDash val="solid"/>
           </a:ln>
@@ -7075,134 +8011,101 @@
       </p:sp>
       <p:sp>
         <p:nvSpPr>
-          <p:cNvPr id="4" name="Text 2"/>
-          <p:cNvSpPr txBox="1"/>
-          <p:nvPr/>
-        </p:nvSpPr>
-        <p:spPr>
-          <a:xfrm>
-            <a:off x="868680" y="1719072"/>
-            <a:ext cx="3063240" cy="274320"/>
-          </a:xfrm>
-          <a:prstGeom prst="rect">
-            <a:avLst/>
-          </a:prstGeom>
-          <a:noFill/>
-          <a:ln/>
-        </p:spPr>
-        <p:txBody>
-          <a:bodyPr wrap="square" lIns="0" tIns="0" rIns="0" bIns="0" rtlCol="0" anchor="ctr"/>
-          <a:lstStyle/>
-          <a:p>
-            <a:pPr indent="0" marL="0">
-              <a:buNone/>
-            </a:pPr>
-            <a:r>
-              <a:rPr lang="en-US" sz="1100" spc="100" kern="0" dirty="0">
-                <a:solidFill>
-                  <a:srgbClr val="6B7280"/>
-                </a:solidFill>
-              </a:rPr>
-              <a:t>PER ASSESSMENT</a:t>
-            </a:r>
-            <a:endParaRPr lang="en-US" sz="1100" dirty="0"/>
-          </a:p>
-        </p:txBody>
-      </p:sp>
-      <p:sp>
-        <p:nvSpPr>
-          <p:cNvPr id="5" name="Text 3"/>
-          <p:cNvSpPr txBox="1"/>
-          <p:nvPr/>
-        </p:nvSpPr>
-        <p:spPr>
-          <a:xfrm>
-            <a:off x="868680" y="2029968"/>
-            <a:ext cx="3063240" cy="658368"/>
-          </a:xfrm>
-          <a:prstGeom prst="rect">
-            <a:avLst/>
-          </a:prstGeom>
-          <a:noFill/>
-          <a:ln/>
-        </p:spPr>
-        <p:txBody>
-          <a:bodyPr wrap="square" lIns="0" tIns="0" rIns="0" bIns="0" rtlCol="0" anchor="ctr"/>
-          <a:lstStyle/>
-          <a:p>
-            <a:pPr indent="0" marL="0">
-              <a:buNone/>
-            </a:pPr>
-            <a:r>
-              <a:rPr lang="en-US" sz="3400" b="1" dirty="0">
-                <a:solidFill>
-                  <a:srgbClr val="E6E9EF"/>
-                </a:solidFill>
-              </a:rPr>
-              <a:t>$0.00012</a:t>
-            </a:r>
-            <a:endParaRPr lang="en-US" sz="3400" dirty="0"/>
-          </a:p>
-        </p:txBody>
-      </p:sp>
-      <p:sp>
-        <p:nvSpPr>
-          <p:cNvPr id="6" name="Text 4"/>
-          <p:cNvSpPr txBox="1"/>
-          <p:nvPr/>
-        </p:nvSpPr>
-        <p:spPr>
-          <a:xfrm>
-            <a:off x="868680" y="2706624"/>
-            <a:ext cx="3063240" cy="292608"/>
-          </a:xfrm>
-          <a:prstGeom prst="rect">
-            <a:avLst/>
-          </a:prstGeom>
-          <a:noFill/>
-          <a:ln/>
-        </p:spPr>
-        <p:txBody>
-          <a:bodyPr wrap="square" lIns="0" tIns="0" rIns="0" bIns="0" rtlCol="0" anchor="ctr"/>
-          <a:lstStyle/>
-          <a:p>
-            <a:pPr indent="0" marL="0">
-              <a:buNone/>
-            </a:pPr>
-            <a:r>
-              <a:rPr lang="en-US" sz="1200" dirty="0">
-                <a:solidFill>
-                  <a:srgbClr val="6B7280"/>
-                </a:solidFill>
-              </a:rPr>
-              <a:t>AMD inference, plus 9 Evolus credits</a:t>
-            </a:r>
-            <a:endParaRPr lang="en-US" sz="1200" dirty="0"/>
-          </a:p>
-        </p:txBody>
-      </p:sp>
-      <p:sp>
-        <p:nvSpPr>
-          <p:cNvPr id="7" name="stat-Time"/>
+          <p:cNvPr id="5" name="Text 2"/>
+          <p:cNvSpPr txBox="1"/>
+          <p:nvPr/>
+        </p:nvSpPr>
+        <p:spPr>
+          <a:xfrm>
+            <a:off x="7863840" y="1828800"/>
+            <a:ext cx="3429000" cy="292608"/>
+          </a:xfrm>
+          <a:prstGeom prst="rect">
+            <a:avLst/>
+          </a:prstGeom>
+          <a:noFill/>
+          <a:ln/>
+        </p:spPr>
+        <p:txBody>
+          <a:bodyPr wrap="square" lIns="0" tIns="0" rIns="0" bIns="0" rtlCol="0" anchor="ctr"/>
+          <a:lstStyle/>
+          <a:p>
+            <a:pPr indent="0" marL="0">
+              <a:buNone/>
+            </a:pPr>
+            <a:r>
+              <a:rPr lang="en-US" sz="1400" b="1" dirty="0">
+                <a:solidFill>
+                  <a:srgbClr val="6366F1"/>
+                </a:solidFill>
+              </a:rPr>
+              <a:t>MinerU, on AMD GPUs</a:t>
+            </a:r>
+            <a:endParaRPr lang="en-US" sz="1400" dirty="0"/>
+          </a:p>
+        </p:txBody>
+      </p:sp>
+      <p:sp>
+        <p:nvSpPr>
+          <p:cNvPr id="6" name="Text 3"/>
+          <p:cNvSpPr txBox="1"/>
+          <p:nvPr/>
+        </p:nvSpPr>
+        <p:spPr>
+          <a:xfrm>
+            <a:off x="7863840" y="2157984"/>
+            <a:ext cx="3429000" cy="731520"/>
+          </a:xfrm>
+          <a:prstGeom prst="rect">
+            <a:avLst/>
+          </a:prstGeom>
+          <a:noFill/>
+          <a:ln/>
+        </p:spPr>
+        <p:txBody>
+          <a:bodyPr wrap="square" lIns="0" tIns="0" rIns="0" bIns="0" rtlCol="0" anchor="ctr"/>
+          <a:lstStyle/>
+          <a:p>
+            <a:pPr indent="0" marL="0">
+              <a:lnSpc>
+                <a:spcPct val="120000"/>
+              </a:lnSpc>
+              <a:buNone/>
+            </a:pPr>
+            <a:r>
+              <a:rPr lang="en-US" sz="1150" dirty="0">
+                <a:solidFill>
+                  <a:srgbClr val="94A3B8"/>
+                </a:solidFill>
+              </a:rPr>
+              <a:t>A PDF or a photo of one, in any language. It takes a base64 data URI, so nothing has to be hosted first.</a:t>
+            </a:r>
+            <a:endParaRPr lang="en-US" sz="1150" dirty="0"/>
+          </a:p>
+        </p:txBody>
+      </p:sp>
+      <p:sp>
+        <p:nvSpPr>
+          <p:cNvPr id="7" name="up-1"/>
           <p:cNvSpPr/>
           <p:nvPr/>
         </p:nvSpPr>
         <p:spPr>
           <a:xfrm>
-            <a:off x="4343400" y="1554480"/>
-            <a:ext cx="3520440" cy="1600200"/>
+            <a:off x="7635240" y="3090672"/>
+            <a:ext cx="3886200" cy="1298448"/>
           </a:xfrm>
           <a:prstGeom prst="roundRect">
             <a:avLst>
-              <a:gd name="adj" fmla="val 4571"/>
+              <a:gd name="adj" fmla="val 5634"/>
             </a:avLst>
           </a:prstGeom>
           <a:solidFill>
-            <a:srgbClr val="161A21"/>
+            <a:srgbClr val="0F172A"/>
           </a:solidFill>
           <a:ln w="12700">
             <a:solidFill>
-              <a:srgbClr val="242A35"/>
+              <a:srgbClr val="1E293B"/>
             </a:solidFill>
             <a:prstDash val="solid"/>
           </a:ln>
@@ -7210,134 +8113,101 @@
       </p:sp>
       <p:sp>
         <p:nvSpPr>
-          <p:cNvPr id="8" name="Text 6"/>
-          <p:cNvSpPr txBox="1"/>
-          <p:nvPr/>
-        </p:nvSpPr>
-        <p:spPr>
-          <a:xfrm>
-            <a:off x="4572000" y="1719072"/>
-            <a:ext cx="3063240" cy="274320"/>
-          </a:xfrm>
-          <a:prstGeom prst="rect">
-            <a:avLst/>
-          </a:prstGeom>
-          <a:noFill/>
-          <a:ln/>
-        </p:spPr>
-        <p:txBody>
-          <a:bodyPr wrap="square" lIns="0" tIns="0" rIns="0" bIns="0" rtlCol="0" anchor="ctr"/>
-          <a:lstStyle/>
-          <a:p>
-            <a:pPr indent="0" marL="0">
-              <a:buNone/>
-            </a:pPr>
-            <a:r>
-              <a:rPr lang="en-US" sz="1100" spc="100" kern="0" dirty="0">
-                <a:solidFill>
-                  <a:srgbClr val="6B7280"/>
-                </a:solidFill>
-              </a:rPr>
-              <a:t>TIME</a:t>
-            </a:r>
-            <a:endParaRPr lang="en-US" sz="1100" dirty="0"/>
-          </a:p>
-        </p:txBody>
-      </p:sp>
-      <p:sp>
-        <p:nvSpPr>
-          <p:cNvPr id="9" name="Text 7"/>
-          <p:cNvSpPr txBox="1"/>
-          <p:nvPr/>
-        </p:nvSpPr>
-        <p:spPr>
-          <a:xfrm>
-            <a:off x="4572000" y="2029968"/>
-            <a:ext cx="3063240" cy="658368"/>
-          </a:xfrm>
-          <a:prstGeom prst="rect">
-            <a:avLst/>
-          </a:prstGeom>
-          <a:noFill/>
-          <a:ln/>
-        </p:spPr>
-        <p:txBody>
-          <a:bodyPr wrap="square" lIns="0" tIns="0" rIns="0" bIns="0" rtlCol="0" anchor="ctr"/>
-          <a:lstStyle/>
-          <a:p>
-            <a:pPr indent="0" marL="0">
-              <a:buNone/>
-            </a:pPr>
-            <a:r>
-              <a:rPr lang="en-US" sz="3400" b="1" dirty="0">
-                <a:solidFill>
-                  <a:srgbClr val="E6E9EF"/>
-                </a:solidFill>
-              </a:rPr>
-              <a:t>Days to 20s</a:t>
-            </a:r>
-            <a:endParaRPr lang="en-US" sz="3400" dirty="0"/>
-          </a:p>
-        </p:txBody>
-      </p:sp>
-      <p:sp>
-        <p:nvSpPr>
-          <p:cNvPr id="10" name="Text 8"/>
-          <p:cNvSpPr txBox="1"/>
-          <p:nvPr/>
-        </p:nvSpPr>
-        <p:spPr>
-          <a:xfrm>
-            <a:off x="4572000" y="2706624"/>
-            <a:ext cx="3063240" cy="292608"/>
-          </a:xfrm>
-          <a:prstGeom prst="rect">
-            <a:avLst/>
-          </a:prstGeom>
-          <a:noFill/>
-          <a:ln/>
-        </p:spPr>
-        <p:txBody>
-          <a:bodyPr wrap="square" lIns="0" tIns="0" rIns="0" bIns="0" rtlCol="0" anchor="ctr"/>
-          <a:lstStyle/>
-          <a:p>
-            <a:pPr indent="0" marL="0">
-              <a:buNone/>
-            </a:pPr>
-            <a:r>
-              <a:rPr lang="en-US" sz="1200" dirty="0">
-                <a:solidFill>
-                  <a:srgbClr val="6B7280"/>
-                </a:solidFill>
-              </a:rPr>
-              <a:t>three people to none</a:t>
-            </a:r>
-            <a:endParaRPr lang="en-US" sz="1200" dirty="0"/>
-          </a:p>
-        </p:txBody>
-      </p:sp>
-      <p:sp>
-        <p:nvSpPr>
-          <p:cNvPr id="11" name="stat-On one part"/>
+          <p:cNvPr id="8" name="Text 5"/>
+          <p:cNvSpPr txBox="1"/>
+          <p:nvPr/>
+        </p:nvSpPr>
+        <p:spPr>
+          <a:xfrm>
+            <a:off x="7863840" y="3273552"/>
+            <a:ext cx="3429000" cy="292608"/>
+          </a:xfrm>
+          <a:prstGeom prst="rect">
+            <a:avLst/>
+          </a:prstGeom>
+          <a:noFill/>
+          <a:ln/>
+        </p:spPr>
+        <p:txBody>
+          <a:bodyPr wrap="square" lIns="0" tIns="0" rIns="0" bIns="0" rtlCol="0" anchor="ctr"/>
+          <a:lstStyle/>
+          <a:p>
+            <a:pPr indent="0" marL="0">
+              <a:buNone/>
+            </a:pPr>
+            <a:r>
+              <a:rPr lang="en-US" sz="1400" b="1" dirty="0">
+                <a:solidFill>
+                  <a:srgbClr val="6366F1"/>
+                </a:solidFill>
+              </a:rPr>
+              <a:t>Reconciled, not trusted</a:t>
+            </a:r>
+            <a:endParaRPr lang="en-US" sz="1400" dirty="0"/>
+          </a:p>
+        </p:txBody>
+      </p:sp>
+      <p:sp>
+        <p:nvSpPr>
+          <p:cNvPr id="9" name="Text 6"/>
+          <p:cNvSpPr txBox="1"/>
+          <p:nvPr/>
+        </p:nvSpPr>
+        <p:spPr>
+          <a:xfrm>
+            <a:off x="7863840" y="3602736"/>
+            <a:ext cx="3429000" cy="731520"/>
+          </a:xfrm>
+          <a:prstGeom prst="rect">
+            <a:avLst/>
+          </a:prstGeom>
+          <a:noFill/>
+          <a:ln/>
+        </p:spPr>
+        <p:txBody>
+          <a:bodyPr wrap="square" lIns="0" tIns="0" rIns="0" bIns="0" rtlCol="0" anchor="ctr"/>
+          <a:lstStyle/>
+          <a:p>
+            <a:pPr indent="0" marL="0">
+              <a:lnSpc>
+                <a:spcPct val="120000"/>
+              </a:lnSpc>
+              <a:buNone/>
+            </a:pPr>
+            <a:r>
+              <a:rPr lang="en-US" sz="1150" dirty="0">
+                <a:solidFill>
+                  <a:srgbClr val="94A3B8"/>
+                </a:solidFill>
+              </a:rPr>
+              <a:t>Part numbers are matched against the real BOM. A notice naming nothing you build is rejected, not assessed.</a:t>
+            </a:r>
+            <a:endParaRPr lang="en-US" sz="1150" dirty="0"/>
+          </a:p>
+        </p:txBody>
+      </p:sp>
+      <p:sp>
+        <p:nvSpPr>
+          <p:cNvPr id="10" name="up-2"/>
           <p:cNvSpPr/>
           <p:nvPr/>
         </p:nvSpPr>
         <p:spPr>
           <a:xfrm>
-            <a:off x="8046720" y="1554480"/>
-            <a:ext cx="3474720" cy="1600200"/>
+            <a:off x="7635240" y="4535424"/>
+            <a:ext cx="3886200" cy="1298448"/>
           </a:xfrm>
           <a:prstGeom prst="roundRect">
             <a:avLst>
-              <a:gd name="adj" fmla="val 4571"/>
+              <a:gd name="adj" fmla="val 5634"/>
             </a:avLst>
           </a:prstGeom>
           <a:solidFill>
-            <a:srgbClr val="161A21"/>
+            <a:srgbClr val="0F172A"/>
           </a:solidFill>
           <a:ln w="12700">
             <a:solidFill>
-              <a:srgbClr val="242A35"/>
+              <a:srgbClr val="1E293B"/>
             </a:solidFill>
             <a:prstDash val="solid"/>
           </a:ln>
@@ -7345,149 +8215,14 @@
       </p:sp>
       <p:sp>
         <p:nvSpPr>
-          <p:cNvPr id="12" name="Text 10"/>
-          <p:cNvSpPr txBox="1"/>
-          <p:nvPr/>
-        </p:nvSpPr>
-        <p:spPr>
-          <a:xfrm>
-            <a:off x="8275320" y="1719072"/>
-            <a:ext cx="3017520" cy="274320"/>
-          </a:xfrm>
-          <a:prstGeom prst="rect">
-            <a:avLst/>
-          </a:prstGeom>
-          <a:noFill/>
-          <a:ln/>
-        </p:spPr>
-        <p:txBody>
-          <a:bodyPr wrap="square" lIns="0" tIns="0" rIns="0" bIns="0" rtlCol="0" anchor="ctr"/>
-          <a:lstStyle/>
-          <a:p>
-            <a:pPr indent="0" marL="0">
-              <a:buNone/>
-            </a:pPr>
-            <a:r>
-              <a:rPr lang="en-US" sz="1100" spc="100" kern="0" dirty="0">
-                <a:solidFill>
-                  <a:srgbClr val="6B7280"/>
-                </a:solidFill>
-              </a:rPr>
-              <a:t>ON ONE PART</a:t>
-            </a:r>
-            <a:endParaRPr lang="en-US" sz="1100" dirty="0"/>
-          </a:p>
-        </p:txBody>
-      </p:sp>
-      <p:sp>
-        <p:nvSpPr>
-          <p:cNvPr id="13" name="Text 11"/>
-          <p:cNvSpPr txBox="1"/>
-          <p:nvPr/>
-        </p:nvSpPr>
-        <p:spPr>
-          <a:xfrm>
-            <a:off x="8275320" y="2029968"/>
-            <a:ext cx="3017520" cy="658368"/>
-          </a:xfrm>
-          <a:prstGeom prst="rect">
-            <a:avLst/>
-          </a:prstGeom>
-          <a:noFill/>
-          <a:ln/>
-        </p:spPr>
-        <p:txBody>
-          <a:bodyPr wrap="square" lIns="0" tIns="0" rIns="0" bIns="0" rtlCol="0" anchor="ctr"/>
-          <a:lstStyle/>
-          <a:p>
-            <a:pPr indent="0" marL="0">
-              <a:buNone/>
-            </a:pPr>
-            <a:r>
-              <a:rPr lang="en-US" sz="3400" b="1" dirty="0">
-                <a:solidFill>
-                  <a:srgbClr val="E6E9EF"/>
-                </a:solidFill>
-              </a:rPr>
-              <a:t>EUR 9.06M</a:t>
-            </a:r>
-            <a:endParaRPr lang="en-US" sz="3400" dirty="0"/>
-          </a:p>
-        </p:txBody>
-      </p:sp>
-      <p:sp>
-        <p:nvSpPr>
-          <p:cNvPr id="14" name="Text 12"/>
-          <p:cNvSpPr txBox="1"/>
-          <p:nvPr/>
-        </p:nvSpPr>
-        <p:spPr>
-          <a:xfrm>
-            <a:off x="8275320" y="2706624"/>
-            <a:ext cx="3017520" cy="292608"/>
-          </a:xfrm>
-          <a:prstGeom prst="rect">
-            <a:avLst/>
-          </a:prstGeom>
-          <a:noFill/>
-          <a:ln/>
-        </p:spPr>
-        <p:txBody>
-          <a:bodyPr wrap="square" lIns="0" tIns="0" rIns="0" bIns="0" rtlCol="0" anchor="ctr"/>
-          <a:lstStyle/>
-          <a:p>
-            <a:pPr indent="0" marL="0">
-              <a:buNone/>
-            </a:pPr>
-            <a:r>
-              <a:rPr lang="en-US" sz="1200" dirty="0">
-                <a:solidFill>
-                  <a:srgbClr val="6B7280"/>
-                </a:solidFill>
-              </a:rPr>
-              <a:t>annual revenue protected</a:t>
-            </a:r>
-            <a:endParaRPr lang="en-US" sz="1200" dirty="0"/>
-          </a:p>
-        </p:txBody>
-      </p:sp>
-      <p:sp>
-        <p:nvSpPr>
-          <p:cNvPr id="15" name="market"/>
-          <p:cNvSpPr/>
-          <p:nvPr/>
-        </p:nvSpPr>
-        <p:spPr>
-          <a:xfrm>
-            <a:off x="640080" y="3429000"/>
-            <a:ext cx="5486400" cy="2194560"/>
-          </a:xfrm>
-          <a:prstGeom prst="roundRect">
-            <a:avLst>
-              <a:gd name="adj" fmla="val 3333"/>
-            </a:avLst>
-          </a:prstGeom>
-          <a:solidFill>
-            <a:srgbClr val="161A21"/>
-          </a:solidFill>
-          <a:ln w="12700">
-            <a:solidFill>
-              <a:srgbClr val="242A35"/>
-            </a:solidFill>
-            <a:prstDash val="solid"/>
-          </a:ln>
-        </p:spPr>
-      </p:sp>
-      <p:sp>
-        <p:nvSpPr>
-          <p:cNvPr id="16" name="Text 14"/>
-          <p:cNvSpPr txBox="1"/>
-          <p:nvPr/>
-        </p:nvSpPr>
-        <p:spPr>
-          <a:xfrm>
-            <a:off x="914400" y="3639312"/>
-            <a:ext cx="4937760" cy="274320"/>
+          <p:cNvPr id="11" name="Text 8"/>
+          <p:cNvSpPr txBox="1"/>
+          <p:nvPr/>
+        </p:nvSpPr>
+        <p:spPr>
+          <a:xfrm>
+            <a:off x="7863840" y="4718304"/>
+            <a:ext cx="3429000" cy="292608"/>
           </a:xfrm>
           <a:prstGeom prst="rect">
             <a:avLst/>
@@ -7505,10 +8240,10 @@
             <a:r>
               <a:rPr lang="en-US" sz="1400" b="1" dirty="0">
                 <a:solidFill>
-                  <a:srgbClr val="F0B429"/>
-                </a:solidFill>
-              </a:rPr>
-              <a:t>The category exists</a:t>
+                  <a:srgbClr val="6366F1"/>
+                </a:solidFill>
+              </a:rPr>
+              <a:t>17 seconds, $0.00006</a:t>
             </a:r>
             <a:endParaRPr lang="en-US" sz="1400" dirty="0"/>
           </a:p>
@@ -7516,14 +8251,14 @@
       </p:sp>
       <p:sp>
         <p:nvSpPr>
-          <p:cNvPr id="17" name="Text 15"/>
-          <p:cNvSpPr txBox="1"/>
-          <p:nvPr/>
-        </p:nvSpPr>
-        <p:spPr>
-          <a:xfrm>
-            <a:off x="914400" y="3977640"/>
-            <a:ext cx="4937760" cy="1554480"/>
+          <p:cNvPr id="12" name="Text 9"/>
+          <p:cNvSpPr txBox="1"/>
+          <p:nvPr/>
+        </p:nvSpPr>
+        <p:spPr>
+          <a:xfrm>
+            <a:off x="7863840" y="5047488"/>
+            <a:ext cx="3429000" cy="731520"/>
           </a:xfrm>
           <a:prstGeom prst="rect">
             <a:avLst/>
@@ -7537,223 +8272,19 @@
           <a:p>
             <a:pPr indent="0" marL="0">
               <a:lnSpc>
-                <a:spcPct val="130000"/>
+                <a:spcPct val="120000"/>
               </a:lnSpc>
               <a:buNone/>
             </a:pPr>
             <a:r>
-              <a:rPr lang="en-US" sz="1300" dirty="0">
-                <a:solidFill>
-                  <a:srgbClr val="9AA3B2"/>
-                </a:solidFill>
-              </a:rPr>
-              <a:t>SiliconExpert, Z2Data and IHS sell obsolescence data today, and manufacturers employ obsolescence managers. That is the proof of willingness to pay.</a:t>
-            </a:r>
-            <a:endParaRPr lang="en-US" sz="1300" dirty="0"/>
-          </a:p>
-          <a:p>
-            <a:pPr indent="0" marL="0">
-              <a:lnSpc>
-                <a:spcPct val="130000"/>
-              </a:lnSpc>
-              <a:buNone/>
-            </a:pPr>
-            <a:endParaRPr lang="en-US" sz="1300" dirty="0"/>
-          </a:p>
-          <a:p>
-            <a:pPr indent="0" marL="0">
-              <a:lnSpc>
-                <a:spcPct val="130000"/>
-              </a:lnSpc>
-              <a:buNone/>
-            </a:pPr>
-            <a:r>
-              <a:rPr lang="en-US" sz="1300" dirty="0">
-                <a:solidFill>
-                  <a:srgbClr val="9AA3B2"/>
-                </a:solidFill>
-              </a:rPr>
-              <a:t>Every one of them is a database you search. This is the first that reads the incoming notice and tells you what breaks.</a:t>
-            </a:r>
-            <a:endParaRPr lang="en-US" sz="1300" dirty="0"/>
-          </a:p>
-        </p:txBody>
-      </p:sp>
-      <p:sp>
-        <p:nvSpPr>
-          <p:cNvPr id="18" name="stack"/>
-          <p:cNvSpPr/>
-          <p:nvPr/>
-        </p:nvSpPr>
-        <p:spPr>
-          <a:xfrm>
-            <a:off x="6492240" y="3429000"/>
-            <a:ext cx="5029200" cy="2194560"/>
-          </a:xfrm>
-          <a:prstGeom prst="roundRect">
-            <a:avLst>
-              <a:gd name="adj" fmla="val 3333"/>
-            </a:avLst>
-          </a:prstGeom>
-          <a:solidFill>
-            <a:srgbClr val="161A21"/>
-          </a:solidFill>
-          <a:ln w="12700">
-            <a:solidFill>
-              <a:srgbClr val="242A35"/>
-            </a:solidFill>
-            <a:prstDash val="solid"/>
-          </a:ln>
-        </p:spPr>
-      </p:sp>
-      <p:sp>
-        <p:nvSpPr>
-          <p:cNvPr id="19" name="Text 17"/>
-          <p:cNvSpPr txBox="1"/>
-          <p:nvPr/>
-        </p:nvSpPr>
-        <p:spPr>
-          <a:xfrm>
-            <a:off x="6766560" y="3639312"/>
-            <a:ext cx="4480560" cy="274320"/>
-          </a:xfrm>
-          <a:prstGeom prst="rect">
-            <a:avLst/>
-          </a:prstGeom>
-          <a:noFill/>
-          <a:ln/>
-        </p:spPr>
-        <p:txBody>
-          <a:bodyPr wrap="square" lIns="0" tIns="0" rIns="0" bIns="0" rtlCol="0" anchor="ctr"/>
-          <a:lstStyle/>
-          <a:p>
-            <a:pPr indent="0" marL="0">
-              <a:buNone/>
-            </a:pPr>
-            <a:r>
-              <a:rPr lang="en-US" sz="1400" b="1" dirty="0">
-                <a:solidFill>
-                  <a:srgbClr val="F0B429"/>
-                </a:solidFill>
-              </a:rPr>
-              <a:t>Built on</a:t>
-            </a:r>
-            <a:endParaRPr lang="en-US" sz="1400" dirty="0"/>
-          </a:p>
-        </p:txBody>
-      </p:sp>
-      <p:sp>
-        <p:nvSpPr>
-          <p:cNvPr id="20" name="Text 18"/>
-          <p:cNvSpPr txBox="1"/>
-          <p:nvPr/>
-        </p:nvSpPr>
-        <p:spPr>
-          <a:xfrm>
-            <a:off x="6766560" y="3977640"/>
-            <a:ext cx="4480560" cy="1554480"/>
-          </a:xfrm>
-          <a:prstGeom prst="rect">
-            <a:avLst/>
-          </a:prstGeom>
-          <a:noFill/>
-          <a:ln/>
-        </p:spPr>
-        <p:txBody>
-          <a:bodyPr wrap="square" rtlCol="0" anchor="ctr"/>
-          <a:lstStyle/>
-          <a:p>
-            <a:pPr indent="0" marL="0">
-              <a:lnSpc>
-                <a:spcPct val="135000"/>
-              </a:lnSpc>
-              <a:buNone/>
-            </a:pPr>
-            <a:r>
-              <a:rPr lang="en-US" sz="1300" b="1" dirty="0">
-                <a:solidFill>
-                  <a:schemeClr val="tx1"/>
-                </a:solidFill>
-              </a:rPr>
-              <a:t>AMD Token Factory  </a:t>
-            </a:r>
-            <a:pPr indent="0" marL="0">
-              <a:lnSpc>
-                <a:spcPct val="135000"/>
-              </a:lnSpc>
-              <a:buNone/>
-            </a:pPr>
-            <a:r>
-              <a:rPr lang="en-US" sz="1300" dirty="0">
-                <a:solidFill>
-                  <a:srgbClr val="9AA3B2"/>
-                </a:solidFill>
-              </a:rPr>
-              <a:t>— every model call, on AMD GPUs</a:t>
-            </a:r>
-            <a:endParaRPr lang="en-US" sz="1300" dirty="0"/>
-          </a:p>
-          <a:p>
-            <a:pPr indent="0" marL="0">
-              <a:lnSpc>
-                <a:spcPct val="135000"/>
-              </a:lnSpc>
-              <a:buNone/>
-            </a:pPr>
-            <a:r>
-              <a:rPr lang="en-US" sz="1300" b="1" dirty="0">
-                <a:solidFill>
-                  <a:schemeClr val="tx1"/>
-                </a:solidFill>
-              </a:rPr>
-              <a:t>Evolus  </a:t>
-            </a:r>
-            <a:pPr indent="0" marL="0">
-              <a:lnSpc>
-                <a:spcPct val="135000"/>
-              </a:lnSpc>
-              <a:buNone/>
-            </a:pPr>
-            <a:r>
-              <a:rPr lang="en-US" sz="1300" dirty="0">
-                <a:solidFill>
-                  <a:srgbClr val="9AA3B2"/>
-                </a:solidFill>
-              </a:rPr>
-              <a:t>— agent on that same AMD endpoint, plus translate, doc-structure and email</a:t>
-            </a:r>
-            <a:endParaRPr lang="en-US" sz="1300" dirty="0"/>
-          </a:p>
-          <a:p>
-            <a:pPr indent="0" marL="0">
-              <a:lnSpc>
-                <a:spcPct val="135000"/>
-              </a:lnSpc>
-              <a:buNone/>
-            </a:pPr>
-            <a:r>
-              <a:rPr lang="en-US" sz="1300" b="1" dirty="0">
-                <a:solidFill>
-                  <a:schemeClr val="tx1"/>
-                </a:solidFill>
-              </a:rPr>
-              <a:t>Impact engine  </a:t>
-            </a:r>
-            <a:pPr indent="0" marL="0">
-              <a:lnSpc>
-                <a:spcPct val="135000"/>
-              </a:lnSpc>
-              <a:buNone/>
-            </a:pPr>
-            <a:r>
-              <a:rPr lang="en-US" sz="1300" dirty="0">
-                <a:solidFill>
-                  <a:srgbClr val="9AA3B2"/>
-                </a:solidFill>
-              </a:rPr>
-              <a:t>— TypeScript, deterministic, auditable</a:t>
-            </a:r>
-            <a:endParaRPr lang="en-US" sz="1300" dirty="0"/>
+              <a:rPr lang="en-US" sz="1150" dirty="0">
+                <a:solidFill>
+                  <a:srgbClr val="94A3B8"/>
+                </a:solidFill>
+              </a:rPr>
+              <a:t>Plus about two Evolus credits. Cheap enough to run on every notice that arrives.</a:t>
+            </a:r>
+            <a:endParaRPr lang="en-US" sz="1150" dirty="0"/>
           </a:p>
         </p:txBody>
       </p:sp>
@@ -7787,7 +8318,7 @@
             <a:lvl1pPr>
               <a:defRPr sz="1000">
                 <a:solidFill>
-                  <a:srgbClr val="6B7280"/>
+                  <a:srgbClr val="64748B"/>
                 </a:solidFill>
                 <a:latin typeface="Arial"/>
                 <a:ea typeface="Arial"/>
@@ -7818,40 +8349,40 @@
   <a:themeElements>
     <a:clrScheme name="LastBuy">
       <a:dk1>
-        <a:srgbClr val="E6E9EF"/>
+        <a:srgbClr val="E2E8F0"/>
       </a:dk1>
       <a:lt1>
-        <a:srgbClr val="0F1115"/>
+        <a:srgbClr val="0B1120"/>
       </a:lt1>
       <a:dk2>
-        <a:srgbClr val="9AA3B2"/>
+        <a:srgbClr val="94A3B8"/>
       </a:dk2>
       <a:lt2>
-        <a:srgbClr val="161A21"/>
+        <a:srgbClr val="0F172A"/>
       </a:lt2>
       <a:accent1>
-        <a:srgbClr val="F0B429"/>
+        <a:srgbClr val="6366F1"/>
       </a:accent1>
       <a:accent2>
-        <a:srgbClr val="F0616D"/>
+        <a:srgbClr val="EF4444"/>
       </a:accent2>
       <a:accent3>
-        <a:srgbClr val="3DD68C"/>
+        <a:srgbClr val="10B981"/>
       </a:accent3>
       <a:accent4>
-        <a:srgbClr val="5AA9E6"/>
+        <a:srgbClr val="A5B4FC"/>
       </a:accent4>
       <a:accent5>
-        <a:srgbClr val="242A35"/>
+        <a:srgbClr val="1E293B"/>
       </a:accent5>
       <a:accent6>
-        <a:srgbClr val="6B7280"/>
+        <a:srgbClr val="64748B"/>
       </a:accent6>
       <a:hlink>
-        <a:srgbClr val="F0B429"/>
+        <a:srgbClr val="6366F1"/>
       </a:hlink>
       <a:folHlink>
-        <a:srgbClr val="9AA3B2"/>
+        <a:srgbClr val="94A3B8"/>
       </a:folHlink>
     </a:clrScheme>
     <a:fontScheme name="LastBuy">

</xml_diff>